<commit_message>
fix(governance-v3): preserve matrix order, regenerate TEST deck at 19/56
- Use non-mutating sort in executive.ts so facilityDocumentation keeps canonical order

- Remove debug logging from adapter.server.ts

- Update generate-governance-v3.ts to emit OM-Governance-Onboarding-Progress-TEST.pptx

- Regenerate TEST deck: 19 approved / 56 required / 34% / 3,11,4,1

- Keep PR #310 Draft
</commit_message>
<xml_diff>
--- a/OM-Governance-Onboarding-Progress-TEST.pptx
+++ b/OM-Governance-Onboarding-Progress-TEST.pptx
@@ -2790,6 +2790,713 @@
                 <a:ea typeface="Arial" pitchFamily="34" charset="-122"/>
                 <a:cs typeface="Arial" pitchFamily="34" charset="-120"/>
               </a:rPr>
+              <a:t>HTT STP</a:t>
+            </a:r>
+            <a:endParaRPr lang="en-US" sz="1300" dirty="0"/>
+          </a:p>
+        </p:txBody>
+      </p:sp>
+      <p:sp>
+        <p:nvSpPr>
+          <p:cNvPr id="54" name="Text 52"/>
+          <p:cNvSpPr/>
+          <p:nvPr/>
+        </p:nvSpPr>
+        <p:spPr>
+          <a:xfrm>
+            <a:off x="594360" y="3456432"/>
+            <a:ext cx="2002536" cy="164592"/>
+          </a:xfrm>
+          <a:prstGeom prst="rect">
+            <a:avLst/>
+          </a:prstGeom>
+          <a:noFill/>
+          <a:ln/>
+        </p:spPr>
+        <p:txBody>
+          <a:bodyPr wrap="square" rtlCol="0" anchor="t"/>
+          <a:lstStyle/>
+          <a:p>
+            <a:pPr algn="l" indent="0" marL="0">
+              <a:buNone/>
+            </a:pPr>
+            <a:r>
+              <a:rPr lang="en-US" sz="1200" dirty="0">
+                <a:solidFill>
+                  <a:srgbClr val="00A9C5"/>
+                </a:solidFill>
+                <a:latin typeface="Arial" pitchFamily="34" charset="0"/>
+                <a:ea typeface="Arial" pitchFamily="34" charset="-122"/>
+                <a:cs typeface="Arial" pitchFamily="34" charset="-120"/>
+              </a:rPr>
+              <a:t>PPP ACTIVE</a:t>
+            </a:r>
+            <a:endParaRPr lang="en-US" sz="1200" dirty="0"/>
+          </a:p>
+        </p:txBody>
+      </p:sp>
+      <p:sp>
+        <p:nvSpPr>
+          <p:cNvPr id="55" name="Text 53"/>
+          <p:cNvSpPr/>
+          <p:nvPr/>
+        </p:nvSpPr>
+        <p:spPr>
+          <a:xfrm>
+            <a:off x="594360" y="3630168"/>
+            <a:ext cx="2002536" cy="164592"/>
+          </a:xfrm>
+          <a:prstGeom prst="rect">
+            <a:avLst/>
+          </a:prstGeom>
+          <a:noFill/>
+          <a:ln/>
+        </p:spPr>
+        <p:txBody>
+          <a:bodyPr wrap="square" rtlCol="0" anchor="t"/>
+          <a:lstStyle/>
+          <a:p>
+            <a:pPr algn="l" indent="0" marL="0">
+              <a:buNone/>
+            </a:pPr>
+            <a:r>
+              <a:rPr lang="en-US" sz="1100" dirty="0">
+                <a:solidFill>
+                  <a:srgbClr val="60758A"/>
+                </a:solidFill>
+                <a:latin typeface="Arial" pitchFamily="34" charset="0"/>
+                <a:ea typeface="Arial" pitchFamily="34" charset="-122"/>
+                <a:cs typeface="Arial" pitchFamily="34" charset="-120"/>
+              </a:rPr>
+              <a:t>PPP START  MAR 13, 2026</a:t>
+            </a:r>
+            <a:endParaRPr lang="en-US" sz="1100" dirty="0"/>
+          </a:p>
+        </p:txBody>
+      </p:sp>
+      <p:sp>
+        <p:nvSpPr>
+          <p:cNvPr id="56" name="Shape 54"/>
+          <p:cNvSpPr/>
+          <p:nvPr/>
+        </p:nvSpPr>
+        <p:spPr>
+          <a:xfrm>
+            <a:off x="2834640" y="3410712"/>
+            <a:ext cx="210312" cy="228600"/>
+          </a:xfrm>
+          <a:prstGeom prst="rect">
+            <a:avLst/>
+          </a:prstGeom>
+          <a:solidFill>
+            <a:srgbClr val="007DA7"/>
+          </a:solidFill>
+          <a:ln/>
+        </p:spPr>
+      </p:sp>
+      <p:sp>
+        <p:nvSpPr>
+          <p:cNvPr id="57" name="Text 55"/>
+          <p:cNvSpPr/>
+          <p:nvPr/>
+        </p:nvSpPr>
+        <p:spPr>
+          <a:xfrm>
+            <a:off x="2834640" y="3410712"/>
+            <a:ext cx="210312" cy="228600"/>
+          </a:xfrm>
+          <a:prstGeom prst="rect">
+            <a:avLst/>
+          </a:prstGeom>
+          <a:noFill/>
+          <a:ln/>
+        </p:spPr>
+        <p:txBody>
+          <a:bodyPr wrap="square" rtlCol="0" anchor="ctr"/>
+          <a:lstStyle/>
+          <a:p>
+            <a:pPr algn="ctr" indent="0" marL="0">
+              <a:buNone/>
+            </a:pPr>
+            <a:r>
+              <a:rPr lang="en-US" sz="1400" b="1" dirty="0">
+                <a:solidFill>
+                  <a:srgbClr val="FFFFFF"/>
+                </a:solidFill>
+                <a:latin typeface="Arial" pitchFamily="34" charset="0"/>
+                <a:ea typeface="Arial" pitchFamily="34" charset="-122"/>
+                <a:cs typeface="Arial" pitchFamily="34" charset="-120"/>
+              </a:rPr>
+              <a:t>✓</a:t>
+            </a:r>
+            <a:endParaRPr lang="en-US" sz="1400" dirty="0"/>
+          </a:p>
+        </p:txBody>
+      </p:sp>
+      <p:sp>
+        <p:nvSpPr>
+          <p:cNvPr id="58" name="Shape 56"/>
+          <p:cNvSpPr/>
+          <p:nvPr/>
+        </p:nvSpPr>
+        <p:spPr>
+          <a:xfrm>
+            <a:off x="3840480" y="3410712"/>
+            <a:ext cx="210312" cy="228600"/>
+          </a:xfrm>
+          <a:prstGeom prst="rect">
+            <a:avLst/>
+          </a:prstGeom>
+          <a:solidFill>
+            <a:srgbClr val="169873"/>
+          </a:solidFill>
+          <a:ln/>
+        </p:spPr>
+      </p:sp>
+      <p:sp>
+        <p:nvSpPr>
+          <p:cNvPr id="59" name="Text 57"/>
+          <p:cNvSpPr/>
+          <p:nvPr/>
+        </p:nvSpPr>
+        <p:spPr>
+          <a:xfrm>
+            <a:off x="3840480" y="3410712"/>
+            <a:ext cx="210312" cy="228600"/>
+          </a:xfrm>
+          <a:prstGeom prst="rect">
+            <a:avLst/>
+          </a:prstGeom>
+          <a:noFill/>
+          <a:ln/>
+        </p:spPr>
+        <p:txBody>
+          <a:bodyPr wrap="square" rtlCol="0" anchor="ctr"/>
+          <a:lstStyle/>
+          <a:p>
+            <a:pPr algn="ctr" indent="0" marL="0">
+              <a:buNone/>
+            </a:pPr>
+            <a:r>
+              <a:rPr lang="en-US" sz="1400" b="1" dirty="0">
+                <a:solidFill>
+                  <a:srgbClr val="FFFFFF"/>
+                </a:solidFill>
+                <a:latin typeface="Arial" pitchFamily="34" charset="0"/>
+                <a:ea typeface="Arial" pitchFamily="34" charset="-122"/>
+                <a:cs typeface="Arial" pitchFamily="34" charset="-120"/>
+              </a:rPr>
+              <a:t>✓</a:t>
+            </a:r>
+            <a:endParaRPr lang="en-US" sz="1400" dirty="0"/>
+          </a:p>
+        </p:txBody>
+      </p:sp>
+      <p:sp>
+        <p:nvSpPr>
+          <p:cNvPr id="60" name="Shape 58"/>
+          <p:cNvSpPr/>
+          <p:nvPr/>
+        </p:nvSpPr>
+        <p:spPr>
+          <a:xfrm>
+            <a:off x="4846320" y="3410712"/>
+            <a:ext cx="210312" cy="228600"/>
+          </a:xfrm>
+          <a:prstGeom prst="rect">
+            <a:avLst/>
+          </a:prstGeom>
+          <a:solidFill>
+            <a:srgbClr val="169873"/>
+          </a:solidFill>
+          <a:ln/>
+        </p:spPr>
+      </p:sp>
+      <p:sp>
+        <p:nvSpPr>
+          <p:cNvPr id="61" name="Text 59"/>
+          <p:cNvSpPr/>
+          <p:nvPr/>
+        </p:nvSpPr>
+        <p:spPr>
+          <a:xfrm>
+            <a:off x="4846320" y="3410712"/>
+            <a:ext cx="210312" cy="228600"/>
+          </a:xfrm>
+          <a:prstGeom prst="rect">
+            <a:avLst/>
+          </a:prstGeom>
+          <a:noFill/>
+          <a:ln/>
+        </p:spPr>
+        <p:txBody>
+          <a:bodyPr wrap="square" rtlCol="0" anchor="ctr"/>
+          <a:lstStyle/>
+          <a:p>
+            <a:pPr algn="ctr" indent="0" marL="0">
+              <a:buNone/>
+            </a:pPr>
+            <a:r>
+              <a:rPr lang="en-US" sz="1400" b="1" dirty="0">
+                <a:solidFill>
+                  <a:srgbClr val="FFFFFF"/>
+                </a:solidFill>
+                <a:latin typeface="Arial" pitchFamily="34" charset="0"/>
+                <a:ea typeface="Arial" pitchFamily="34" charset="-122"/>
+                <a:cs typeface="Arial" pitchFamily="34" charset="-120"/>
+              </a:rPr>
+              <a:t>✓</a:t>
+            </a:r>
+            <a:endParaRPr lang="en-US" sz="1400" dirty="0"/>
+          </a:p>
+        </p:txBody>
+      </p:sp>
+      <p:sp>
+        <p:nvSpPr>
+          <p:cNvPr id="62" name="Shape 60"/>
+          <p:cNvSpPr/>
+          <p:nvPr/>
+        </p:nvSpPr>
+        <p:spPr>
+          <a:xfrm>
+            <a:off x="5852160" y="3410712"/>
+            <a:ext cx="210312" cy="228600"/>
+          </a:xfrm>
+          <a:prstGeom prst="rect">
+            <a:avLst/>
+          </a:prstGeom>
+          <a:solidFill>
+            <a:srgbClr val="EEF2F5"/>
+          </a:solidFill>
+          <a:ln/>
+        </p:spPr>
+      </p:sp>
+      <p:sp>
+        <p:nvSpPr>
+          <p:cNvPr id="63" name="Text 61"/>
+          <p:cNvSpPr/>
+          <p:nvPr/>
+        </p:nvSpPr>
+        <p:spPr>
+          <a:xfrm>
+            <a:off x="5852160" y="3410712"/>
+            <a:ext cx="210312" cy="228600"/>
+          </a:xfrm>
+          <a:prstGeom prst="rect">
+            <a:avLst/>
+          </a:prstGeom>
+          <a:noFill/>
+          <a:ln/>
+        </p:spPr>
+        <p:txBody>
+          <a:bodyPr wrap="square" rtlCol="0" anchor="ctr"/>
+          <a:lstStyle/>
+          <a:p>
+            <a:pPr algn="ctr" indent="0" marL="0">
+              <a:buNone/>
+            </a:pPr>
+            <a:r>
+              <a:rPr lang="en-US" sz="1400" b="1" dirty="0">
+                <a:solidFill>
+                  <a:srgbClr val="60758A"/>
+                </a:solidFill>
+                <a:latin typeface="Arial" pitchFamily="34" charset="0"/>
+                <a:ea typeface="Arial" pitchFamily="34" charset="-122"/>
+                <a:cs typeface="Arial" pitchFamily="34" charset="-120"/>
+              </a:rPr>
+              <a:t>○</a:t>
+            </a:r>
+            <a:endParaRPr lang="en-US" sz="1400" dirty="0"/>
+          </a:p>
+        </p:txBody>
+      </p:sp>
+      <p:sp>
+        <p:nvSpPr>
+          <p:cNvPr id="64" name="Shape 62"/>
+          <p:cNvSpPr/>
+          <p:nvPr/>
+        </p:nvSpPr>
+        <p:spPr>
+          <a:xfrm>
+            <a:off x="6858000" y="3410712"/>
+            <a:ext cx="210312" cy="228600"/>
+          </a:xfrm>
+          <a:prstGeom prst="rect">
+            <a:avLst/>
+          </a:prstGeom>
+          <a:solidFill>
+            <a:srgbClr val="169873"/>
+          </a:solidFill>
+          <a:ln/>
+        </p:spPr>
+      </p:sp>
+      <p:sp>
+        <p:nvSpPr>
+          <p:cNvPr id="65" name="Text 63"/>
+          <p:cNvSpPr/>
+          <p:nvPr/>
+        </p:nvSpPr>
+        <p:spPr>
+          <a:xfrm>
+            <a:off x="6858000" y="3410712"/>
+            <a:ext cx="210312" cy="228600"/>
+          </a:xfrm>
+          <a:prstGeom prst="rect">
+            <a:avLst/>
+          </a:prstGeom>
+          <a:noFill/>
+          <a:ln/>
+        </p:spPr>
+        <p:txBody>
+          <a:bodyPr wrap="square" rtlCol="0" anchor="ctr"/>
+          <a:lstStyle/>
+          <a:p>
+            <a:pPr algn="ctr" indent="0" marL="0">
+              <a:buNone/>
+            </a:pPr>
+            <a:r>
+              <a:rPr lang="en-US" sz="1400" b="1" dirty="0">
+                <a:solidFill>
+                  <a:srgbClr val="FFFFFF"/>
+                </a:solidFill>
+                <a:latin typeface="Arial" pitchFamily="34" charset="0"/>
+                <a:ea typeface="Arial" pitchFamily="34" charset="-122"/>
+                <a:cs typeface="Arial" pitchFamily="34" charset="-120"/>
+              </a:rPr>
+              <a:t>✓</a:t>
+            </a:r>
+            <a:endParaRPr lang="en-US" sz="1400" dirty="0"/>
+          </a:p>
+        </p:txBody>
+      </p:sp>
+      <p:sp>
+        <p:nvSpPr>
+          <p:cNvPr id="66" name="Shape 64"/>
+          <p:cNvSpPr/>
+          <p:nvPr/>
+        </p:nvSpPr>
+        <p:spPr>
+          <a:xfrm>
+            <a:off x="7863840" y="3410712"/>
+            <a:ext cx="210312" cy="228600"/>
+          </a:xfrm>
+          <a:prstGeom prst="rect">
+            <a:avLst/>
+          </a:prstGeom>
+          <a:solidFill>
+            <a:srgbClr val="EEF2F5"/>
+          </a:solidFill>
+          <a:ln/>
+        </p:spPr>
+      </p:sp>
+      <p:sp>
+        <p:nvSpPr>
+          <p:cNvPr id="67" name="Text 65"/>
+          <p:cNvSpPr/>
+          <p:nvPr/>
+        </p:nvSpPr>
+        <p:spPr>
+          <a:xfrm>
+            <a:off x="7863840" y="3410712"/>
+            <a:ext cx="210312" cy="228600"/>
+          </a:xfrm>
+          <a:prstGeom prst="rect">
+            <a:avLst/>
+          </a:prstGeom>
+          <a:noFill/>
+          <a:ln/>
+        </p:spPr>
+        <p:txBody>
+          <a:bodyPr wrap="square" rtlCol="0" anchor="ctr"/>
+          <a:lstStyle/>
+          <a:p>
+            <a:pPr algn="ctr" indent="0" marL="0">
+              <a:buNone/>
+            </a:pPr>
+            <a:r>
+              <a:rPr lang="en-US" sz="1400" b="1" dirty="0">
+                <a:solidFill>
+                  <a:srgbClr val="60758A"/>
+                </a:solidFill>
+                <a:latin typeface="Arial" pitchFamily="34" charset="0"/>
+                <a:ea typeface="Arial" pitchFamily="34" charset="-122"/>
+                <a:cs typeface="Arial" pitchFamily="34" charset="-120"/>
+              </a:rPr>
+              <a:t>○</a:t>
+            </a:r>
+            <a:endParaRPr lang="en-US" sz="1400" dirty="0"/>
+          </a:p>
+        </p:txBody>
+      </p:sp>
+      <p:sp>
+        <p:nvSpPr>
+          <p:cNvPr id="68" name="Shape 66"/>
+          <p:cNvSpPr/>
+          <p:nvPr/>
+        </p:nvSpPr>
+        <p:spPr>
+          <a:xfrm>
+            <a:off x="8869680" y="3410712"/>
+            <a:ext cx="210312" cy="228600"/>
+          </a:xfrm>
+          <a:prstGeom prst="rect">
+            <a:avLst/>
+          </a:prstGeom>
+          <a:solidFill>
+            <a:srgbClr val="EEF2F5"/>
+          </a:solidFill>
+          <a:ln/>
+        </p:spPr>
+      </p:sp>
+      <p:sp>
+        <p:nvSpPr>
+          <p:cNvPr id="69" name="Text 67"/>
+          <p:cNvSpPr/>
+          <p:nvPr/>
+        </p:nvSpPr>
+        <p:spPr>
+          <a:xfrm>
+            <a:off x="8869680" y="3410712"/>
+            <a:ext cx="210312" cy="228600"/>
+          </a:xfrm>
+          <a:prstGeom prst="rect">
+            <a:avLst/>
+          </a:prstGeom>
+          <a:noFill/>
+          <a:ln/>
+        </p:spPr>
+        <p:txBody>
+          <a:bodyPr wrap="square" rtlCol="0" anchor="ctr"/>
+          <a:lstStyle/>
+          <a:p>
+            <a:pPr algn="ctr" indent="0" marL="0">
+              <a:buNone/>
+            </a:pPr>
+            <a:r>
+              <a:rPr lang="en-US" sz="1400" b="1" dirty="0">
+                <a:solidFill>
+                  <a:srgbClr val="60758A"/>
+                </a:solidFill>
+                <a:latin typeface="Arial" pitchFamily="34" charset="0"/>
+                <a:ea typeface="Arial" pitchFamily="34" charset="-122"/>
+                <a:cs typeface="Arial" pitchFamily="34" charset="-120"/>
+              </a:rPr>
+              <a:t>○</a:t>
+            </a:r>
+            <a:endParaRPr lang="en-US" sz="1400" dirty="0"/>
+          </a:p>
+        </p:txBody>
+      </p:sp>
+      <p:sp>
+        <p:nvSpPr>
+          <p:cNvPr id="70" name="Shape 68"/>
+          <p:cNvSpPr/>
+          <p:nvPr/>
+        </p:nvSpPr>
+        <p:spPr>
+          <a:xfrm>
+            <a:off x="9875520" y="3410712"/>
+            <a:ext cx="210312" cy="228600"/>
+          </a:xfrm>
+          <a:prstGeom prst="rect">
+            <a:avLst/>
+          </a:prstGeom>
+          <a:solidFill>
+            <a:srgbClr val="EEF2F5"/>
+          </a:solidFill>
+          <a:ln/>
+        </p:spPr>
+      </p:sp>
+      <p:sp>
+        <p:nvSpPr>
+          <p:cNvPr id="71" name="Text 69"/>
+          <p:cNvSpPr/>
+          <p:nvPr/>
+        </p:nvSpPr>
+        <p:spPr>
+          <a:xfrm>
+            <a:off x="9875520" y="3410712"/>
+            <a:ext cx="210312" cy="228600"/>
+          </a:xfrm>
+          <a:prstGeom prst="rect">
+            <a:avLst/>
+          </a:prstGeom>
+          <a:noFill/>
+          <a:ln/>
+        </p:spPr>
+        <p:txBody>
+          <a:bodyPr wrap="square" rtlCol="0" anchor="ctr"/>
+          <a:lstStyle/>
+          <a:p>
+            <a:pPr algn="ctr" indent="0" marL="0">
+              <a:buNone/>
+            </a:pPr>
+            <a:r>
+              <a:rPr lang="en-US" sz="1400" b="1" dirty="0">
+                <a:solidFill>
+                  <a:srgbClr val="60758A"/>
+                </a:solidFill>
+                <a:latin typeface="Arial" pitchFamily="34" charset="0"/>
+                <a:ea typeface="Arial" pitchFamily="34" charset="-122"/>
+                <a:cs typeface="Arial" pitchFamily="34" charset="-120"/>
+              </a:rPr>
+              <a:t>○</a:t>
+            </a:r>
+            <a:endParaRPr lang="en-US" sz="1400" dirty="0"/>
+          </a:p>
+        </p:txBody>
+      </p:sp>
+      <p:sp>
+        <p:nvSpPr>
+          <p:cNvPr id="72" name="Shape 70"/>
+          <p:cNvSpPr/>
+          <p:nvPr/>
+        </p:nvSpPr>
+        <p:spPr>
+          <a:xfrm>
+            <a:off x="10881360" y="3410712"/>
+            <a:ext cx="210312" cy="228600"/>
+          </a:xfrm>
+          <a:prstGeom prst="rect">
+            <a:avLst/>
+          </a:prstGeom>
+          <a:solidFill>
+            <a:srgbClr val="EEF2F5"/>
+          </a:solidFill>
+          <a:ln/>
+        </p:spPr>
+      </p:sp>
+      <p:sp>
+        <p:nvSpPr>
+          <p:cNvPr id="73" name="Text 71"/>
+          <p:cNvSpPr/>
+          <p:nvPr/>
+        </p:nvSpPr>
+        <p:spPr>
+          <a:xfrm>
+            <a:off x="10881360" y="3410712"/>
+            <a:ext cx="210312" cy="228600"/>
+          </a:xfrm>
+          <a:prstGeom prst="rect">
+            <a:avLst/>
+          </a:prstGeom>
+          <a:noFill/>
+          <a:ln/>
+        </p:spPr>
+        <p:txBody>
+          <a:bodyPr wrap="square" rtlCol="0" anchor="ctr"/>
+          <a:lstStyle/>
+          <a:p>
+            <a:pPr algn="ctr" indent="0" marL="0">
+              <a:buNone/>
+            </a:pPr>
+            <a:r>
+              <a:rPr lang="en-US" sz="1400" b="1" dirty="0">
+                <a:solidFill>
+                  <a:srgbClr val="60758A"/>
+                </a:solidFill>
+                <a:latin typeface="Arial" pitchFamily="34" charset="0"/>
+                <a:ea typeface="Arial" pitchFamily="34" charset="-122"/>
+                <a:cs typeface="Arial" pitchFamily="34" charset="-120"/>
+              </a:rPr>
+              <a:t>○</a:t>
+            </a:r>
+            <a:endParaRPr lang="en-US" sz="1400" dirty="0"/>
+          </a:p>
+        </p:txBody>
+      </p:sp>
+      <p:sp>
+        <p:nvSpPr>
+          <p:cNvPr id="74" name="Text 72"/>
+          <p:cNvSpPr/>
+          <p:nvPr/>
+        </p:nvSpPr>
+        <p:spPr>
+          <a:xfrm>
+            <a:off x="2578608" y="3840480"/>
+            <a:ext cx="8887968" cy="365760"/>
+          </a:xfrm>
+          <a:prstGeom prst="rect">
+            <a:avLst/>
+          </a:prstGeom>
+          <a:noFill/>
+          <a:ln/>
+        </p:spPr>
+        <p:txBody>
+          <a:bodyPr wrap="square" rtlCol="0" anchor="t"/>
+          <a:lstStyle/>
+          <a:p>
+            <a:pPr algn="l" indent="0" marL="0">
+              <a:buNone/>
+            </a:pPr>
+            <a:r>
+              <a:rPr lang="en-US" sz="1100" dirty="0">
+                <a:solidFill>
+                  <a:srgbClr val="17324F"/>
+                </a:solidFill>
+                <a:latin typeface="Arial" pitchFamily="34" charset="0"/>
+                <a:ea typeface="Arial" pitchFamily="34" charset="-122"/>
+                <a:cs typeface="Arial" pitchFamily="34" charset="-120"/>
+              </a:rPr>
+              <a:t>HTT: Active PPP with 79% documentation compliance.</a:t>
+            </a:r>
+            <a:endParaRPr lang="en-US" sz="1100" dirty="0"/>
+          </a:p>
+        </p:txBody>
+      </p:sp>
+      <p:sp>
+        <p:nvSpPr>
+          <p:cNvPr id="75" name="Shape 73"/>
+          <p:cNvSpPr/>
+          <p:nvPr/>
+        </p:nvSpPr>
+        <p:spPr>
+          <a:xfrm>
+            <a:off x="457200" y="4160520"/>
+            <a:ext cx="137160" cy="1005840"/>
+          </a:xfrm>
+          <a:prstGeom prst="rect">
+            <a:avLst/>
+          </a:prstGeom>
+          <a:solidFill>
+            <a:srgbClr val="00A9C5"/>
+          </a:solidFill>
+          <a:ln/>
+        </p:spPr>
+      </p:sp>
+      <p:sp>
+        <p:nvSpPr>
+          <p:cNvPr id="76" name="Text 74"/>
+          <p:cNvSpPr/>
+          <p:nvPr/>
+        </p:nvSpPr>
+        <p:spPr>
+          <a:xfrm>
+            <a:off x="594360" y="4251960"/>
+            <a:ext cx="2002536" cy="201168"/>
+          </a:xfrm>
+          <a:prstGeom prst="rect">
+            <a:avLst/>
+          </a:prstGeom>
+          <a:noFill/>
+          <a:ln/>
+        </p:spPr>
+        <p:txBody>
+          <a:bodyPr wrap="square" rtlCol="0" anchor="t"/>
+          <a:lstStyle/>
+          <a:p>
+            <a:pPr algn="l" indent="0" marL="0">
+              <a:buNone/>
+            </a:pPr>
+            <a:r>
+              <a:rPr lang="en-US" sz="1300" b="1" dirty="0">
+                <a:solidFill>
+                  <a:srgbClr val="08264C"/>
+                </a:solidFill>
+                <a:latin typeface="Arial" pitchFamily="34" charset="0"/>
+                <a:ea typeface="Arial" pitchFamily="34" charset="-122"/>
+                <a:cs typeface="Arial" pitchFamily="34" charset="-120"/>
+              </a:rPr>
               <a:t>EASTBAY PH-2 TP</a:t>
             </a:r>
             <a:endParaRPr lang="en-US" sz="1300" dirty="0"/>
@@ -2798,13 +3505,13 @@
       </p:sp>
       <p:sp>
         <p:nvSpPr>
-          <p:cNvPr id="54" name="Text 52"/>
-          <p:cNvSpPr/>
-          <p:nvPr/>
-        </p:nvSpPr>
-        <p:spPr>
-          <a:xfrm>
-            <a:off x="594360" y="3456432"/>
+          <p:cNvPr id="77" name="Text 75"/>
+          <p:cNvSpPr/>
+          <p:nvPr/>
+        </p:nvSpPr>
+        <p:spPr>
+          <a:xfrm>
+            <a:off x="594360" y="4462272"/>
             <a:ext cx="2002536" cy="164592"/>
           </a:xfrm>
           <a:prstGeom prst="rect">
@@ -2837,13 +3544,13 @@
       </p:sp>
       <p:sp>
         <p:nvSpPr>
-          <p:cNvPr id="55" name="Text 53"/>
-          <p:cNvSpPr/>
-          <p:nvPr/>
-        </p:nvSpPr>
-        <p:spPr>
-          <a:xfrm>
-            <a:off x="594360" y="3630168"/>
+          <p:cNvPr id="78" name="Text 76"/>
+          <p:cNvSpPr/>
+          <p:nvPr/>
+        </p:nvSpPr>
+        <p:spPr>
+          <a:xfrm>
+            <a:off x="594360" y="4636008"/>
             <a:ext cx="2002536" cy="164592"/>
           </a:xfrm>
           <a:prstGeom prst="rect">
@@ -2876,13 +3583,13 @@
       </p:sp>
       <p:sp>
         <p:nvSpPr>
-          <p:cNvPr id="56" name="Shape 54"/>
-          <p:cNvSpPr/>
-          <p:nvPr/>
-        </p:nvSpPr>
-        <p:spPr>
-          <a:xfrm>
-            <a:off x="2834640" y="3410712"/>
+          <p:cNvPr id="79" name="Shape 77"/>
+          <p:cNvSpPr/>
+          <p:nvPr/>
+        </p:nvSpPr>
+        <p:spPr>
+          <a:xfrm>
+            <a:off x="2834640" y="4416552"/>
             <a:ext cx="210312" cy="228600"/>
           </a:xfrm>
           <a:prstGeom prst="rect">
@@ -2896,13 +3603,13 @@
       </p:sp>
       <p:sp>
         <p:nvSpPr>
-          <p:cNvPr id="57" name="Text 55"/>
-          <p:cNvSpPr/>
-          <p:nvPr/>
-        </p:nvSpPr>
-        <p:spPr>
-          <a:xfrm>
-            <a:off x="2834640" y="3410712"/>
+          <p:cNvPr id="80" name="Text 78"/>
+          <p:cNvSpPr/>
+          <p:nvPr/>
+        </p:nvSpPr>
+        <p:spPr>
+          <a:xfrm>
+            <a:off x="2834640" y="4416552"/>
             <a:ext cx="210312" cy="228600"/>
           </a:xfrm>
           <a:prstGeom prst="rect">
@@ -2935,13 +3642,13 @@
       </p:sp>
       <p:sp>
         <p:nvSpPr>
-          <p:cNvPr id="58" name="Shape 56"/>
-          <p:cNvSpPr/>
-          <p:nvPr/>
-        </p:nvSpPr>
-        <p:spPr>
-          <a:xfrm>
-            <a:off x="3840480" y="3410712"/>
+          <p:cNvPr id="81" name="Shape 79"/>
+          <p:cNvSpPr/>
+          <p:nvPr/>
+        </p:nvSpPr>
+        <p:spPr>
+          <a:xfrm>
+            <a:off x="3840480" y="4416552"/>
             <a:ext cx="210312" cy="228600"/>
           </a:xfrm>
           <a:prstGeom prst="rect">
@@ -2955,13 +3662,13 @@
       </p:sp>
       <p:sp>
         <p:nvSpPr>
-          <p:cNvPr id="59" name="Text 57"/>
-          <p:cNvSpPr/>
-          <p:nvPr/>
-        </p:nvSpPr>
-        <p:spPr>
-          <a:xfrm>
-            <a:off x="3840480" y="3410712"/>
+          <p:cNvPr id="82" name="Text 80"/>
+          <p:cNvSpPr/>
+          <p:nvPr/>
+        </p:nvSpPr>
+        <p:spPr>
+          <a:xfrm>
+            <a:off x="3840480" y="4416552"/>
             <a:ext cx="210312" cy="228600"/>
           </a:xfrm>
           <a:prstGeom prst="rect">
@@ -2994,13 +3701,13 @@
       </p:sp>
       <p:sp>
         <p:nvSpPr>
-          <p:cNvPr id="60" name="Shape 58"/>
-          <p:cNvSpPr/>
-          <p:nvPr/>
-        </p:nvSpPr>
-        <p:spPr>
-          <a:xfrm>
-            <a:off x="4846320" y="3410712"/>
+          <p:cNvPr id="83" name="Shape 81"/>
+          <p:cNvSpPr/>
+          <p:nvPr/>
+        </p:nvSpPr>
+        <p:spPr>
+          <a:xfrm>
+            <a:off x="4846320" y="4416552"/>
             <a:ext cx="210312" cy="228600"/>
           </a:xfrm>
           <a:prstGeom prst="rect">
@@ -3014,13 +3721,13 @@
       </p:sp>
       <p:sp>
         <p:nvSpPr>
-          <p:cNvPr id="61" name="Text 59"/>
-          <p:cNvSpPr/>
-          <p:nvPr/>
-        </p:nvSpPr>
-        <p:spPr>
-          <a:xfrm>
-            <a:off x="4846320" y="3410712"/>
+          <p:cNvPr id="84" name="Text 82"/>
+          <p:cNvSpPr/>
+          <p:nvPr/>
+        </p:nvSpPr>
+        <p:spPr>
+          <a:xfrm>
+            <a:off x="4846320" y="4416552"/>
             <a:ext cx="210312" cy="228600"/>
           </a:xfrm>
           <a:prstGeom prst="rect">
@@ -3053,13 +3760,13 @@
       </p:sp>
       <p:sp>
         <p:nvSpPr>
-          <p:cNvPr id="62" name="Shape 60"/>
-          <p:cNvSpPr/>
-          <p:nvPr/>
-        </p:nvSpPr>
-        <p:spPr>
-          <a:xfrm>
-            <a:off x="5852160" y="3410712"/>
+          <p:cNvPr id="85" name="Shape 83"/>
+          <p:cNvSpPr/>
+          <p:nvPr/>
+        </p:nvSpPr>
+        <p:spPr>
+          <a:xfrm>
+            <a:off x="5852160" y="4416552"/>
             <a:ext cx="210312" cy="228600"/>
           </a:xfrm>
           <a:prstGeom prst="rect">
@@ -3073,13 +3780,13 @@
       </p:sp>
       <p:sp>
         <p:nvSpPr>
-          <p:cNvPr id="63" name="Text 61"/>
-          <p:cNvSpPr/>
-          <p:nvPr/>
-        </p:nvSpPr>
-        <p:spPr>
-          <a:xfrm>
-            <a:off x="5852160" y="3410712"/>
+          <p:cNvPr id="86" name="Text 84"/>
+          <p:cNvSpPr/>
+          <p:nvPr/>
+        </p:nvSpPr>
+        <p:spPr>
+          <a:xfrm>
+            <a:off x="5852160" y="4416552"/>
             <a:ext cx="210312" cy="228600"/>
           </a:xfrm>
           <a:prstGeom prst="rect">
@@ -3112,13 +3819,13 @@
       </p:sp>
       <p:sp>
         <p:nvSpPr>
-          <p:cNvPr id="64" name="Shape 62"/>
-          <p:cNvSpPr/>
-          <p:nvPr/>
-        </p:nvSpPr>
-        <p:spPr>
-          <a:xfrm>
-            <a:off x="6858000" y="3410712"/>
+          <p:cNvPr id="87" name="Shape 85"/>
+          <p:cNvSpPr/>
+          <p:nvPr/>
+        </p:nvSpPr>
+        <p:spPr>
+          <a:xfrm>
+            <a:off x="6858000" y="4416552"/>
             <a:ext cx="210312" cy="228600"/>
           </a:xfrm>
           <a:prstGeom prst="rect">
@@ -3132,13 +3839,13 @@
       </p:sp>
       <p:sp>
         <p:nvSpPr>
-          <p:cNvPr id="65" name="Text 63"/>
-          <p:cNvSpPr/>
-          <p:nvPr/>
-        </p:nvSpPr>
-        <p:spPr>
-          <a:xfrm>
-            <a:off x="6858000" y="3410712"/>
+          <p:cNvPr id="88" name="Text 86"/>
+          <p:cNvSpPr/>
+          <p:nvPr/>
+        </p:nvSpPr>
+        <p:spPr>
+          <a:xfrm>
+            <a:off x="6858000" y="4416552"/>
             <a:ext cx="210312" cy="228600"/>
           </a:xfrm>
           <a:prstGeom prst="rect">
@@ -3171,13 +3878,13 @@
       </p:sp>
       <p:sp>
         <p:nvSpPr>
-          <p:cNvPr id="66" name="Shape 64"/>
-          <p:cNvSpPr/>
-          <p:nvPr/>
-        </p:nvSpPr>
-        <p:spPr>
-          <a:xfrm>
-            <a:off x="7863840" y="3410712"/>
+          <p:cNvPr id="89" name="Shape 87"/>
+          <p:cNvSpPr/>
+          <p:nvPr/>
+        </p:nvSpPr>
+        <p:spPr>
+          <a:xfrm>
+            <a:off x="7863840" y="4416552"/>
             <a:ext cx="210312" cy="228600"/>
           </a:xfrm>
           <a:prstGeom prst="rect">
@@ -3191,13 +3898,13 @@
       </p:sp>
       <p:sp>
         <p:nvSpPr>
-          <p:cNvPr id="67" name="Text 65"/>
-          <p:cNvSpPr/>
-          <p:nvPr/>
-        </p:nvSpPr>
-        <p:spPr>
-          <a:xfrm>
-            <a:off x="7863840" y="3410712"/>
+          <p:cNvPr id="90" name="Text 88"/>
+          <p:cNvSpPr/>
+          <p:nvPr/>
+        </p:nvSpPr>
+        <p:spPr>
+          <a:xfrm>
+            <a:off x="7863840" y="4416552"/>
             <a:ext cx="210312" cy="228600"/>
           </a:xfrm>
           <a:prstGeom prst="rect">
@@ -3230,13 +3937,13 @@
       </p:sp>
       <p:sp>
         <p:nvSpPr>
-          <p:cNvPr id="68" name="Shape 66"/>
-          <p:cNvSpPr/>
-          <p:nvPr/>
-        </p:nvSpPr>
-        <p:spPr>
-          <a:xfrm>
-            <a:off x="8869680" y="3410712"/>
+          <p:cNvPr id="91" name="Shape 89"/>
+          <p:cNvSpPr/>
+          <p:nvPr/>
+        </p:nvSpPr>
+        <p:spPr>
+          <a:xfrm>
+            <a:off x="8869680" y="4416552"/>
             <a:ext cx="210312" cy="228600"/>
           </a:xfrm>
           <a:prstGeom prst="rect">
@@ -3250,13 +3957,13 @@
       </p:sp>
       <p:sp>
         <p:nvSpPr>
-          <p:cNvPr id="69" name="Text 67"/>
-          <p:cNvSpPr/>
-          <p:nvPr/>
-        </p:nvSpPr>
-        <p:spPr>
-          <a:xfrm>
-            <a:off x="8869680" y="3410712"/>
+          <p:cNvPr id="92" name="Text 90"/>
+          <p:cNvSpPr/>
+          <p:nvPr/>
+        </p:nvSpPr>
+        <p:spPr>
+          <a:xfrm>
+            <a:off x="8869680" y="4416552"/>
             <a:ext cx="210312" cy="228600"/>
           </a:xfrm>
           <a:prstGeom prst="rect">
@@ -3289,13 +3996,13 @@
       </p:sp>
       <p:sp>
         <p:nvSpPr>
-          <p:cNvPr id="70" name="Shape 68"/>
-          <p:cNvSpPr/>
-          <p:nvPr/>
-        </p:nvSpPr>
-        <p:spPr>
-          <a:xfrm>
-            <a:off x="9875520" y="3410712"/>
+          <p:cNvPr id="93" name="Shape 91"/>
+          <p:cNvSpPr/>
+          <p:nvPr/>
+        </p:nvSpPr>
+        <p:spPr>
+          <a:xfrm>
+            <a:off x="9875520" y="4416552"/>
             <a:ext cx="210312" cy="228600"/>
           </a:xfrm>
           <a:prstGeom prst="rect">
@@ -3309,13 +4016,13 @@
       </p:sp>
       <p:sp>
         <p:nvSpPr>
-          <p:cNvPr id="71" name="Text 69"/>
-          <p:cNvSpPr/>
-          <p:nvPr/>
-        </p:nvSpPr>
-        <p:spPr>
-          <a:xfrm>
-            <a:off x="9875520" y="3410712"/>
+          <p:cNvPr id="94" name="Text 92"/>
+          <p:cNvSpPr/>
+          <p:nvPr/>
+        </p:nvSpPr>
+        <p:spPr>
+          <a:xfrm>
+            <a:off x="9875520" y="4416552"/>
             <a:ext cx="210312" cy="228600"/>
           </a:xfrm>
           <a:prstGeom prst="rect">
@@ -3348,13 +4055,13 @@
       </p:sp>
       <p:sp>
         <p:nvSpPr>
-          <p:cNvPr id="72" name="Shape 70"/>
-          <p:cNvSpPr/>
-          <p:nvPr/>
-        </p:nvSpPr>
-        <p:spPr>
-          <a:xfrm>
-            <a:off x="10881360" y="3410712"/>
+          <p:cNvPr id="95" name="Shape 93"/>
+          <p:cNvSpPr/>
+          <p:nvPr/>
+        </p:nvSpPr>
+        <p:spPr>
+          <a:xfrm>
+            <a:off x="10881360" y="4416552"/>
             <a:ext cx="210312" cy="228600"/>
           </a:xfrm>
           <a:prstGeom prst="rect">
@@ -3368,13 +4075,13 @@
       </p:sp>
       <p:sp>
         <p:nvSpPr>
-          <p:cNvPr id="73" name="Text 71"/>
-          <p:cNvSpPr/>
-          <p:nvPr/>
-        </p:nvSpPr>
-        <p:spPr>
-          <a:xfrm>
-            <a:off x="10881360" y="3410712"/>
+          <p:cNvPr id="96" name="Text 94"/>
+          <p:cNvSpPr/>
+          <p:nvPr/>
+        </p:nvSpPr>
+        <p:spPr>
+          <a:xfrm>
+            <a:off x="10881360" y="4416552"/>
             <a:ext cx="210312" cy="228600"/>
           </a:xfrm>
           <a:prstGeom prst="rect">
@@ -3407,13 +4114,13 @@
       </p:sp>
       <p:sp>
         <p:nvSpPr>
-          <p:cNvPr id="74" name="Text 72"/>
-          <p:cNvSpPr/>
-          <p:nvPr/>
-        </p:nvSpPr>
-        <p:spPr>
-          <a:xfrm>
-            <a:off x="2578608" y="3840480"/>
+          <p:cNvPr id="97" name="Text 95"/>
+          <p:cNvSpPr/>
+          <p:nvPr/>
+        </p:nvSpPr>
+        <p:spPr>
+          <a:xfrm>
+            <a:off x="2578608" y="4846320"/>
             <a:ext cx="8887968" cy="365760"/>
           </a:xfrm>
           <a:prstGeom prst="rect">
@@ -3439,713 +4146,6 @@
                 <a:cs typeface="Arial" pitchFamily="34" charset="-120"/>
               </a:rPr>
               <a:t>EASTBAY: Pre-PPP readiness at 29% documentation compliance.</a:t>
-            </a:r>
-            <a:endParaRPr lang="en-US" sz="1100" dirty="0"/>
-          </a:p>
-        </p:txBody>
-      </p:sp>
-      <p:sp>
-        <p:nvSpPr>
-          <p:cNvPr id="75" name="Shape 73"/>
-          <p:cNvSpPr/>
-          <p:nvPr/>
-        </p:nvSpPr>
-        <p:spPr>
-          <a:xfrm>
-            <a:off x="457200" y="4160520"/>
-            <a:ext cx="137160" cy="1005840"/>
-          </a:xfrm>
-          <a:prstGeom prst="rect">
-            <a:avLst/>
-          </a:prstGeom>
-          <a:solidFill>
-            <a:srgbClr val="00A9C5"/>
-          </a:solidFill>
-          <a:ln/>
-        </p:spPr>
-      </p:sp>
-      <p:sp>
-        <p:nvSpPr>
-          <p:cNvPr id="76" name="Text 74"/>
-          <p:cNvSpPr/>
-          <p:nvPr/>
-        </p:nvSpPr>
-        <p:spPr>
-          <a:xfrm>
-            <a:off x="594360" y="4251960"/>
-            <a:ext cx="2002536" cy="201168"/>
-          </a:xfrm>
-          <a:prstGeom prst="rect">
-            <a:avLst/>
-          </a:prstGeom>
-          <a:noFill/>
-          <a:ln/>
-        </p:spPr>
-        <p:txBody>
-          <a:bodyPr wrap="square" rtlCol="0" anchor="t"/>
-          <a:lstStyle/>
-          <a:p>
-            <a:pPr algn="l" indent="0" marL="0">
-              <a:buNone/>
-            </a:pPr>
-            <a:r>
-              <a:rPr lang="en-US" sz="1300" b="1" dirty="0">
-                <a:solidFill>
-                  <a:srgbClr val="08264C"/>
-                </a:solidFill>
-                <a:latin typeface="Arial" pitchFamily="34" charset="0"/>
-                <a:ea typeface="Arial" pitchFamily="34" charset="-122"/>
-                <a:cs typeface="Arial" pitchFamily="34" charset="-120"/>
-              </a:rPr>
-              <a:t>HTT STP</a:t>
-            </a:r>
-            <a:endParaRPr lang="en-US" sz="1300" dirty="0"/>
-          </a:p>
-        </p:txBody>
-      </p:sp>
-      <p:sp>
-        <p:nvSpPr>
-          <p:cNvPr id="77" name="Text 75"/>
-          <p:cNvSpPr/>
-          <p:nvPr/>
-        </p:nvSpPr>
-        <p:spPr>
-          <a:xfrm>
-            <a:off x="594360" y="4462272"/>
-            <a:ext cx="2002536" cy="164592"/>
-          </a:xfrm>
-          <a:prstGeom prst="rect">
-            <a:avLst/>
-          </a:prstGeom>
-          <a:noFill/>
-          <a:ln/>
-        </p:spPr>
-        <p:txBody>
-          <a:bodyPr wrap="square" rtlCol="0" anchor="t"/>
-          <a:lstStyle/>
-          <a:p>
-            <a:pPr algn="l" indent="0" marL="0">
-              <a:buNone/>
-            </a:pPr>
-            <a:r>
-              <a:rPr lang="en-US" sz="1200" dirty="0">
-                <a:solidFill>
-                  <a:srgbClr val="00A9C5"/>
-                </a:solidFill>
-                <a:latin typeface="Arial" pitchFamily="34" charset="0"/>
-                <a:ea typeface="Arial" pitchFamily="34" charset="-122"/>
-                <a:cs typeface="Arial" pitchFamily="34" charset="-120"/>
-              </a:rPr>
-              <a:t>PPP ACTIVE</a:t>
-            </a:r>
-            <a:endParaRPr lang="en-US" sz="1200" dirty="0"/>
-          </a:p>
-        </p:txBody>
-      </p:sp>
-      <p:sp>
-        <p:nvSpPr>
-          <p:cNvPr id="78" name="Text 76"/>
-          <p:cNvSpPr/>
-          <p:nvPr/>
-        </p:nvSpPr>
-        <p:spPr>
-          <a:xfrm>
-            <a:off x="594360" y="4636008"/>
-            <a:ext cx="2002536" cy="164592"/>
-          </a:xfrm>
-          <a:prstGeom prst="rect">
-            <a:avLst/>
-          </a:prstGeom>
-          <a:noFill/>
-          <a:ln/>
-        </p:spPr>
-        <p:txBody>
-          <a:bodyPr wrap="square" rtlCol="0" anchor="t"/>
-          <a:lstStyle/>
-          <a:p>
-            <a:pPr algn="l" indent="0" marL="0">
-              <a:buNone/>
-            </a:pPr>
-            <a:r>
-              <a:rPr lang="en-US" sz="1100" dirty="0">
-                <a:solidFill>
-                  <a:srgbClr val="60758A"/>
-                </a:solidFill>
-                <a:latin typeface="Arial" pitchFamily="34" charset="0"/>
-                <a:ea typeface="Arial" pitchFamily="34" charset="-122"/>
-                <a:cs typeface="Arial" pitchFamily="34" charset="-120"/>
-              </a:rPr>
-              <a:t>PPP START  MAR 13, 2026</a:t>
-            </a:r>
-            <a:endParaRPr lang="en-US" sz="1100" dirty="0"/>
-          </a:p>
-        </p:txBody>
-      </p:sp>
-      <p:sp>
-        <p:nvSpPr>
-          <p:cNvPr id="79" name="Shape 77"/>
-          <p:cNvSpPr/>
-          <p:nvPr/>
-        </p:nvSpPr>
-        <p:spPr>
-          <a:xfrm>
-            <a:off x="2834640" y="4416552"/>
-            <a:ext cx="210312" cy="228600"/>
-          </a:xfrm>
-          <a:prstGeom prst="rect">
-            <a:avLst/>
-          </a:prstGeom>
-          <a:solidFill>
-            <a:srgbClr val="007DA7"/>
-          </a:solidFill>
-          <a:ln/>
-        </p:spPr>
-      </p:sp>
-      <p:sp>
-        <p:nvSpPr>
-          <p:cNvPr id="80" name="Text 78"/>
-          <p:cNvSpPr/>
-          <p:nvPr/>
-        </p:nvSpPr>
-        <p:spPr>
-          <a:xfrm>
-            <a:off x="2834640" y="4416552"/>
-            <a:ext cx="210312" cy="228600"/>
-          </a:xfrm>
-          <a:prstGeom prst="rect">
-            <a:avLst/>
-          </a:prstGeom>
-          <a:noFill/>
-          <a:ln/>
-        </p:spPr>
-        <p:txBody>
-          <a:bodyPr wrap="square" rtlCol="0" anchor="ctr"/>
-          <a:lstStyle/>
-          <a:p>
-            <a:pPr algn="ctr" indent="0" marL="0">
-              <a:buNone/>
-            </a:pPr>
-            <a:r>
-              <a:rPr lang="en-US" sz="1400" b="1" dirty="0">
-                <a:solidFill>
-                  <a:srgbClr val="FFFFFF"/>
-                </a:solidFill>
-                <a:latin typeface="Arial" pitchFamily="34" charset="0"/>
-                <a:ea typeface="Arial" pitchFamily="34" charset="-122"/>
-                <a:cs typeface="Arial" pitchFamily="34" charset="-120"/>
-              </a:rPr>
-              <a:t>✓</a:t>
-            </a:r>
-            <a:endParaRPr lang="en-US" sz="1400" dirty="0"/>
-          </a:p>
-        </p:txBody>
-      </p:sp>
-      <p:sp>
-        <p:nvSpPr>
-          <p:cNvPr id="81" name="Shape 79"/>
-          <p:cNvSpPr/>
-          <p:nvPr/>
-        </p:nvSpPr>
-        <p:spPr>
-          <a:xfrm>
-            <a:off x="3840480" y="4416552"/>
-            <a:ext cx="210312" cy="228600"/>
-          </a:xfrm>
-          <a:prstGeom prst="rect">
-            <a:avLst/>
-          </a:prstGeom>
-          <a:solidFill>
-            <a:srgbClr val="169873"/>
-          </a:solidFill>
-          <a:ln/>
-        </p:spPr>
-      </p:sp>
-      <p:sp>
-        <p:nvSpPr>
-          <p:cNvPr id="82" name="Text 80"/>
-          <p:cNvSpPr/>
-          <p:nvPr/>
-        </p:nvSpPr>
-        <p:spPr>
-          <a:xfrm>
-            <a:off x="3840480" y="4416552"/>
-            <a:ext cx="210312" cy="228600"/>
-          </a:xfrm>
-          <a:prstGeom prst="rect">
-            <a:avLst/>
-          </a:prstGeom>
-          <a:noFill/>
-          <a:ln/>
-        </p:spPr>
-        <p:txBody>
-          <a:bodyPr wrap="square" rtlCol="0" anchor="ctr"/>
-          <a:lstStyle/>
-          <a:p>
-            <a:pPr algn="ctr" indent="0" marL="0">
-              <a:buNone/>
-            </a:pPr>
-            <a:r>
-              <a:rPr lang="en-US" sz="1400" b="1" dirty="0">
-                <a:solidFill>
-                  <a:srgbClr val="FFFFFF"/>
-                </a:solidFill>
-                <a:latin typeface="Arial" pitchFamily="34" charset="0"/>
-                <a:ea typeface="Arial" pitchFamily="34" charset="-122"/>
-                <a:cs typeface="Arial" pitchFamily="34" charset="-120"/>
-              </a:rPr>
-              <a:t>✓</a:t>
-            </a:r>
-            <a:endParaRPr lang="en-US" sz="1400" dirty="0"/>
-          </a:p>
-        </p:txBody>
-      </p:sp>
-      <p:sp>
-        <p:nvSpPr>
-          <p:cNvPr id="83" name="Shape 81"/>
-          <p:cNvSpPr/>
-          <p:nvPr/>
-        </p:nvSpPr>
-        <p:spPr>
-          <a:xfrm>
-            <a:off x="4846320" y="4416552"/>
-            <a:ext cx="210312" cy="228600"/>
-          </a:xfrm>
-          <a:prstGeom prst="rect">
-            <a:avLst/>
-          </a:prstGeom>
-          <a:solidFill>
-            <a:srgbClr val="169873"/>
-          </a:solidFill>
-          <a:ln/>
-        </p:spPr>
-      </p:sp>
-      <p:sp>
-        <p:nvSpPr>
-          <p:cNvPr id="84" name="Text 82"/>
-          <p:cNvSpPr/>
-          <p:nvPr/>
-        </p:nvSpPr>
-        <p:spPr>
-          <a:xfrm>
-            <a:off x="4846320" y="4416552"/>
-            <a:ext cx="210312" cy="228600"/>
-          </a:xfrm>
-          <a:prstGeom prst="rect">
-            <a:avLst/>
-          </a:prstGeom>
-          <a:noFill/>
-          <a:ln/>
-        </p:spPr>
-        <p:txBody>
-          <a:bodyPr wrap="square" rtlCol="0" anchor="ctr"/>
-          <a:lstStyle/>
-          <a:p>
-            <a:pPr algn="ctr" indent="0" marL="0">
-              <a:buNone/>
-            </a:pPr>
-            <a:r>
-              <a:rPr lang="en-US" sz="1400" b="1" dirty="0">
-                <a:solidFill>
-                  <a:srgbClr val="FFFFFF"/>
-                </a:solidFill>
-                <a:latin typeface="Arial" pitchFamily="34" charset="0"/>
-                <a:ea typeface="Arial" pitchFamily="34" charset="-122"/>
-                <a:cs typeface="Arial" pitchFamily="34" charset="-120"/>
-              </a:rPr>
-              <a:t>✓</a:t>
-            </a:r>
-            <a:endParaRPr lang="en-US" sz="1400" dirty="0"/>
-          </a:p>
-        </p:txBody>
-      </p:sp>
-      <p:sp>
-        <p:nvSpPr>
-          <p:cNvPr id="85" name="Shape 83"/>
-          <p:cNvSpPr/>
-          <p:nvPr/>
-        </p:nvSpPr>
-        <p:spPr>
-          <a:xfrm>
-            <a:off x="5852160" y="4416552"/>
-            <a:ext cx="210312" cy="228600"/>
-          </a:xfrm>
-          <a:prstGeom prst="rect">
-            <a:avLst/>
-          </a:prstGeom>
-          <a:solidFill>
-            <a:srgbClr val="EEF2F5"/>
-          </a:solidFill>
-          <a:ln/>
-        </p:spPr>
-      </p:sp>
-      <p:sp>
-        <p:nvSpPr>
-          <p:cNvPr id="86" name="Text 84"/>
-          <p:cNvSpPr/>
-          <p:nvPr/>
-        </p:nvSpPr>
-        <p:spPr>
-          <a:xfrm>
-            <a:off x="5852160" y="4416552"/>
-            <a:ext cx="210312" cy="228600"/>
-          </a:xfrm>
-          <a:prstGeom prst="rect">
-            <a:avLst/>
-          </a:prstGeom>
-          <a:noFill/>
-          <a:ln/>
-        </p:spPr>
-        <p:txBody>
-          <a:bodyPr wrap="square" rtlCol="0" anchor="ctr"/>
-          <a:lstStyle/>
-          <a:p>
-            <a:pPr algn="ctr" indent="0" marL="0">
-              <a:buNone/>
-            </a:pPr>
-            <a:r>
-              <a:rPr lang="en-US" sz="1400" b="1" dirty="0">
-                <a:solidFill>
-                  <a:srgbClr val="60758A"/>
-                </a:solidFill>
-                <a:latin typeface="Arial" pitchFamily="34" charset="0"/>
-                <a:ea typeface="Arial" pitchFamily="34" charset="-122"/>
-                <a:cs typeface="Arial" pitchFamily="34" charset="-120"/>
-              </a:rPr>
-              <a:t>○</a:t>
-            </a:r>
-            <a:endParaRPr lang="en-US" sz="1400" dirty="0"/>
-          </a:p>
-        </p:txBody>
-      </p:sp>
-      <p:sp>
-        <p:nvSpPr>
-          <p:cNvPr id="87" name="Shape 85"/>
-          <p:cNvSpPr/>
-          <p:nvPr/>
-        </p:nvSpPr>
-        <p:spPr>
-          <a:xfrm>
-            <a:off x="6858000" y="4416552"/>
-            <a:ext cx="210312" cy="228600"/>
-          </a:xfrm>
-          <a:prstGeom prst="rect">
-            <a:avLst/>
-          </a:prstGeom>
-          <a:solidFill>
-            <a:srgbClr val="169873"/>
-          </a:solidFill>
-          <a:ln/>
-        </p:spPr>
-      </p:sp>
-      <p:sp>
-        <p:nvSpPr>
-          <p:cNvPr id="88" name="Text 86"/>
-          <p:cNvSpPr/>
-          <p:nvPr/>
-        </p:nvSpPr>
-        <p:spPr>
-          <a:xfrm>
-            <a:off x="6858000" y="4416552"/>
-            <a:ext cx="210312" cy="228600"/>
-          </a:xfrm>
-          <a:prstGeom prst="rect">
-            <a:avLst/>
-          </a:prstGeom>
-          <a:noFill/>
-          <a:ln/>
-        </p:spPr>
-        <p:txBody>
-          <a:bodyPr wrap="square" rtlCol="0" anchor="ctr"/>
-          <a:lstStyle/>
-          <a:p>
-            <a:pPr algn="ctr" indent="0" marL="0">
-              <a:buNone/>
-            </a:pPr>
-            <a:r>
-              <a:rPr lang="en-US" sz="1400" b="1" dirty="0">
-                <a:solidFill>
-                  <a:srgbClr val="FFFFFF"/>
-                </a:solidFill>
-                <a:latin typeface="Arial" pitchFamily="34" charset="0"/>
-                <a:ea typeface="Arial" pitchFamily="34" charset="-122"/>
-                <a:cs typeface="Arial" pitchFamily="34" charset="-120"/>
-              </a:rPr>
-              <a:t>✓</a:t>
-            </a:r>
-            <a:endParaRPr lang="en-US" sz="1400" dirty="0"/>
-          </a:p>
-        </p:txBody>
-      </p:sp>
-      <p:sp>
-        <p:nvSpPr>
-          <p:cNvPr id="89" name="Shape 87"/>
-          <p:cNvSpPr/>
-          <p:nvPr/>
-        </p:nvSpPr>
-        <p:spPr>
-          <a:xfrm>
-            <a:off x="7863840" y="4416552"/>
-            <a:ext cx="210312" cy="228600"/>
-          </a:xfrm>
-          <a:prstGeom prst="rect">
-            <a:avLst/>
-          </a:prstGeom>
-          <a:solidFill>
-            <a:srgbClr val="EEF2F5"/>
-          </a:solidFill>
-          <a:ln/>
-        </p:spPr>
-      </p:sp>
-      <p:sp>
-        <p:nvSpPr>
-          <p:cNvPr id="90" name="Text 88"/>
-          <p:cNvSpPr/>
-          <p:nvPr/>
-        </p:nvSpPr>
-        <p:spPr>
-          <a:xfrm>
-            <a:off x="7863840" y="4416552"/>
-            <a:ext cx="210312" cy="228600"/>
-          </a:xfrm>
-          <a:prstGeom prst="rect">
-            <a:avLst/>
-          </a:prstGeom>
-          <a:noFill/>
-          <a:ln/>
-        </p:spPr>
-        <p:txBody>
-          <a:bodyPr wrap="square" rtlCol="0" anchor="ctr"/>
-          <a:lstStyle/>
-          <a:p>
-            <a:pPr algn="ctr" indent="0" marL="0">
-              <a:buNone/>
-            </a:pPr>
-            <a:r>
-              <a:rPr lang="en-US" sz="1400" b="1" dirty="0">
-                <a:solidFill>
-                  <a:srgbClr val="60758A"/>
-                </a:solidFill>
-                <a:latin typeface="Arial" pitchFamily="34" charset="0"/>
-                <a:ea typeface="Arial" pitchFamily="34" charset="-122"/>
-                <a:cs typeface="Arial" pitchFamily="34" charset="-120"/>
-              </a:rPr>
-              <a:t>○</a:t>
-            </a:r>
-            <a:endParaRPr lang="en-US" sz="1400" dirty="0"/>
-          </a:p>
-        </p:txBody>
-      </p:sp>
-      <p:sp>
-        <p:nvSpPr>
-          <p:cNvPr id="91" name="Shape 89"/>
-          <p:cNvSpPr/>
-          <p:nvPr/>
-        </p:nvSpPr>
-        <p:spPr>
-          <a:xfrm>
-            <a:off x="8869680" y="4416552"/>
-            <a:ext cx="210312" cy="228600"/>
-          </a:xfrm>
-          <a:prstGeom prst="rect">
-            <a:avLst/>
-          </a:prstGeom>
-          <a:solidFill>
-            <a:srgbClr val="EEF2F5"/>
-          </a:solidFill>
-          <a:ln/>
-        </p:spPr>
-      </p:sp>
-      <p:sp>
-        <p:nvSpPr>
-          <p:cNvPr id="92" name="Text 90"/>
-          <p:cNvSpPr/>
-          <p:nvPr/>
-        </p:nvSpPr>
-        <p:spPr>
-          <a:xfrm>
-            <a:off x="8869680" y="4416552"/>
-            <a:ext cx="210312" cy="228600"/>
-          </a:xfrm>
-          <a:prstGeom prst="rect">
-            <a:avLst/>
-          </a:prstGeom>
-          <a:noFill/>
-          <a:ln/>
-        </p:spPr>
-        <p:txBody>
-          <a:bodyPr wrap="square" rtlCol="0" anchor="ctr"/>
-          <a:lstStyle/>
-          <a:p>
-            <a:pPr algn="ctr" indent="0" marL="0">
-              <a:buNone/>
-            </a:pPr>
-            <a:r>
-              <a:rPr lang="en-US" sz="1400" b="1" dirty="0">
-                <a:solidFill>
-                  <a:srgbClr val="60758A"/>
-                </a:solidFill>
-                <a:latin typeface="Arial" pitchFamily="34" charset="0"/>
-                <a:ea typeface="Arial" pitchFamily="34" charset="-122"/>
-                <a:cs typeface="Arial" pitchFamily="34" charset="-120"/>
-              </a:rPr>
-              <a:t>○</a:t>
-            </a:r>
-            <a:endParaRPr lang="en-US" sz="1400" dirty="0"/>
-          </a:p>
-        </p:txBody>
-      </p:sp>
-      <p:sp>
-        <p:nvSpPr>
-          <p:cNvPr id="93" name="Shape 91"/>
-          <p:cNvSpPr/>
-          <p:nvPr/>
-        </p:nvSpPr>
-        <p:spPr>
-          <a:xfrm>
-            <a:off x="9875520" y="4416552"/>
-            <a:ext cx="210312" cy="228600"/>
-          </a:xfrm>
-          <a:prstGeom prst="rect">
-            <a:avLst/>
-          </a:prstGeom>
-          <a:solidFill>
-            <a:srgbClr val="EEF2F5"/>
-          </a:solidFill>
-          <a:ln/>
-        </p:spPr>
-      </p:sp>
-      <p:sp>
-        <p:nvSpPr>
-          <p:cNvPr id="94" name="Text 92"/>
-          <p:cNvSpPr/>
-          <p:nvPr/>
-        </p:nvSpPr>
-        <p:spPr>
-          <a:xfrm>
-            <a:off x="9875520" y="4416552"/>
-            <a:ext cx="210312" cy="228600"/>
-          </a:xfrm>
-          <a:prstGeom prst="rect">
-            <a:avLst/>
-          </a:prstGeom>
-          <a:noFill/>
-          <a:ln/>
-        </p:spPr>
-        <p:txBody>
-          <a:bodyPr wrap="square" rtlCol="0" anchor="ctr"/>
-          <a:lstStyle/>
-          <a:p>
-            <a:pPr algn="ctr" indent="0" marL="0">
-              <a:buNone/>
-            </a:pPr>
-            <a:r>
-              <a:rPr lang="en-US" sz="1400" b="1" dirty="0">
-                <a:solidFill>
-                  <a:srgbClr val="60758A"/>
-                </a:solidFill>
-                <a:latin typeface="Arial" pitchFamily="34" charset="0"/>
-                <a:ea typeface="Arial" pitchFamily="34" charset="-122"/>
-                <a:cs typeface="Arial" pitchFamily="34" charset="-120"/>
-              </a:rPr>
-              <a:t>○</a:t>
-            </a:r>
-            <a:endParaRPr lang="en-US" sz="1400" dirty="0"/>
-          </a:p>
-        </p:txBody>
-      </p:sp>
-      <p:sp>
-        <p:nvSpPr>
-          <p:cNvPr id="95" name="Shape 93"/>
-          <p:cNvSpPr/>
-          <p:nvPr/>
-        </p:nvSpPr>
-        <p:spPr>
-          <a:xfrm>
-            <a:off x="10881360" y="4416552"/>
-            <a:ext cx="210312" cy="228600"/>
-          </a:xfrm>
-          <a:prstGeom prst="rect">
-            <a:avLst/>
-          </a:prstGeom>
-          <a:solidFill>
-            <a:srgbClr val="EEF2F5"/>
-          </a:solidFill>
-          <a:ln/>
-        </p:spPr>
-      </p:sp>
-      <p:sp>
-        <p:nvSpPr>
-          <p:cNvPr id="96" name="Text 94"/>
-          <p:cNvSpPr/>
-          <p:nvPr/>
-        </p:nvSpPr>
-        <p:spPr>
-          <a:xfrm>
-            <a:off x="10881360" y="4416552"/>
-            <a:ext cx="210312" cy="228600"/>
-          </a:xfrm>
-          <a:prstGeom prst="rect">
-            <a:avLst/>
-          </a:prstGeom>
-          <a:noFill/>
-          <a:ln/>
-        </p:spPr>
-        <p:txBody>
-          <a:bodyPr wrap="square" rtlCol="0" anchor="ctr"/>
-          <a:lstStyle/>
-          <a:p>
-            <a:pPr algn="ctr" indent="0" marL="0">
-              <a:buNone/>
-            </a:pPr>
-            <a:r>
-              <a:rPr lang="en-US" sz="1400" b="1" dirty="0">
-                <a:solidFill>
-                  <a:srgbClr val="60758A"/>
-                </a:solidFill>
-                <a:latin typeface="Arial" pitchFamily="34" charset="0"/>
-                <a:ea typeface="Arial" pitchFamily="34" charset="-122"/>
-                <a:cs typeface="Arial" pitchFamily="34" charset="-120"/>
-              </a:rPr>
-              <a:t>○</a:t>
-            </a:r>
-            <a:endParaRPr lang="en-US" sz="1400" dirty="0"/>
-          </a:p>
-        </p:txBody>
-      </p:sp>
-      <p:sp>
-        <p:nvSpPr>
-          <p:cNvPr id="97" name="Text 95"/>
-          <p:cNvSpPr/>
-          <p:nvPr/>
-        </p:nvSpPr>
-        <p:spPr>
-          <a:xfrm>
-            <a:off x="2578608" y="4846320"/>
-            <a:ext cx="8887968" cy="365760"/>
-          </a:xfrm>
-          <a:prstGeom prst="rect">
-            <a:avLst/>
-          </a:prstGeom>
-          <a:noFill/>
-          <a:ln/>
-        </p:spPr>
-        <p:txBody>
-          <a:bodyPr wrap="square" rtlCol="0" anchor="t"/>
-          <a:lstStyle/>
-          <a:p>
-            <a:pPr algn="l" indent="0" marL="0">
-              <a:buNone/>
-            </a:pPr>
-            <a:r>
-              <a:rPr lang="en-US" sz="1100" dirty="0">
-                <a:solidFill>
-                  <a:srgbClr val="17324F"/>
-                </a:solidFill>
-                <a:latin typeface="Arial" pitchFamily="34" charset="0"/>
-                <a:ea typeface="Arial" pitchFamily="34" charset="-122"/>
-                <a:cs typeface="Arial" pitchFamily="34" charset="-120"/>
-              </a:rPr>
-              <a:t>HTT: Active PPP with 79% documentation compliance.</a:t>
             </a:r>
             <a:endParaRPr lang="en-US" sz="1100" dirty="0"/>
           </a:p>
@@ -6772,6 +6772,262 @@
                 <a:ea typeface="Arial" pitchFamily="34" charset="-122"/>
                 <a:cs typeface="Arial" pitchFamily="34" charset="-120"/>
               </a:rPr>
+              <a:t>HTT STP</a:t>
+            </a:r>
+            <a:endParaRPr lang="en-US" sz="1300" dirty="0"/>
+          </a:p>
+        </p:txBody>
+      </p:sp>
+      <p:sp>
+        <p:nvSpPr>
+          <p:cNvPr id="47" name="Text 45"/>
+          <p:cNvSpPr/>
+          <p:nvPr/>
+        </p:nvSpPr>
+        <p:spPr>
+          <a:xfrm>
+            <a:off x="457200" y="2953512"/>
+            <a:ext cx="2002536" cy="182880"/>
+          </a:xfrm>
+          <a:prstGeom prst="rect">
+            <a:avLst/>
+          </a:prstGeom>
+          <a:noFill/>
+          <a:ln/>
+        </p:spPr>
+        <p:txBody>
+          <a:bodyPr wrap="square" rtlCol="0" anchor="t"/>
+          <a:lstStyle/>
+          <a:p>
+            <a:pPr algn="l" indent="0" marL="0">
+              <a:buNone/>
+            </a:pPr>
+            <a:r>
+              <a:rPr lang="en-US" sz="1200" dirty="0">
+                <a:solidFill>
+                  <a:srgbClr val="60758A"/>
+                </a:solidFill>
+                <a:latin typeface="Arial" pitchFamily="34" charset="0"/>
+                <a:ea typeface="Arial" pitchFamily="34" charset="-122"/>
+                <a:cs typeface="Arial" pitchFamily="34" charset="-120"/>
+              </a:rPr>
+              <a:t>PPP: MAR 2026</a:t>
+            </a:r>
+            <a:endParaRPr lang="en-US" sz="1200" dirty="0"/>
+          </a:p>
+        </p:txBody>
+      </p:sp>
+      <p:sp>
+        <p:nvSpPr>
+          <p:cNvPr id="48" name="Shape 46"/>
+          <p:cNvSpPr/>
+          <p:nvPr/>
+        </p:nvSpPr>
+        <p:spPr>
+          <a:xfrm>
+            <a:off x="4066032" y="2880360"/>
+            <a:ext cx="146304" cy="228600"/>
+          </a:xfrm>
+          <a:prstGeom prst="rect">
+            <a:avLst/>
+          </a:prstGeom>
+          <a:solidFill>
+            <a:srgbClr val="08264C"/>
+          </a:solidFill>
+          <a:ln/>
+        </p:spPr>
+      </p:sp>
+      <p:sp>
+        <p:nvSpPr>
+          <p:cNvPr id="49" name="Shape 47"/>
+          <p:cNvSpPr/>
+          <p:nvPr/>
+        </p:nvSpPr>
+        <p:spPr>
+          <a:xfrm>
+            <a:off x="7010400" y="2880360"/>
+            <a:ext cx="146304" cy="228600"/>
+          </a:xfrm>
+          <a:prstGeom prst="rect">
+            <a:avLst/>
+          </a:prstGeom>
+          <a:solidFill>
+            <a:srgbClr val="08264C"/>
+          </a:solidFill>
+          <a:ln/>
+        </p:spPr>
+      </p:sp>
+      <p:sp>
+        <p:nvSpPr>
+          <p:cNvPr id="50" name="Shape 48"/>
+          <p:cNvSpPr/>
+          <p:nvPr/>
+        </p:nvSpPr>
+        <p:spPr>
+          <a:xfrm>
+            <a:off x="4139184" y="2926080"/>
+            <a:ext cx="981456" cy="137160"/>
+          </a:xfrm>
+          <a:prstGeom prst="rect">
+            <a:avLst/>
+          </a:prstGeom>
+          <a:solidFill>
+            <a:srgbClr val="00A9C5"/>
+          </a:solidFill>
+          <a:ln/>
+        </p:spPr>
+      </p:sp>
+      <p:sp>
+        <p:nvSpPr>
+          <p:cNvPr id="51" name="Shape 49"/>
+          <p:cNvSpPr/>
+          <p:nvPr/>
+        </p:nvSpPr>
+        <p:spPr>
+          <a:xfrm>
+            <a:off x="5120640" y="2926080"/>
+            <a:ext cx="1962912" cy="137160"/>
+          </a:xfrm>
+          <a:prstGeom prst="rect">
+            <a:avLst/>
+          </a:prstGeom>
+          <a:solidFill>
+            <a:srgbClr val="A8D5E5"/>
+          </a:solidFill>
+          <a:ln/>
+        </p:spPr>
+      </p:sp>
+      <p:sp>
+        <p:nvSpPr>
+          <p:cNvPr id="52" name="Text 50"/>
+          <p:cNvSpPr/>
+          <p:nvPr/>
+        </p:nvSpPr>
+        <p:spPr>
+          <a:xfrm>
+            <a:off x="5257800" y="2880360"/>
+            <a:ext cx="2286000" cy="228600"/>
+          </a:xfrm>
+          <a:prstGeom prst="rect">
+            <a:avLst/>
+          </a:prstGeom>
+          <a:noFill/>
+          <a:ln/>
+        </p:spPr>
+        <p:txBody>
+          <a:bodyPr wrap="square" rtlCol="0" anchor="t"/>
+          <a:lstStyle/>
+          <a:p>
+            <a:pPr algn="l" indent="0" marL="0">
+              <a:buNone/>
+            </a:pPr>
+            <a:r>
+              <a:rPr lang="en-US" sz="1200" b="1" dirty="0">
+                <a:solidFill>
+                  <a:srgbClr val="00A9C5"/>
+                </a:solidFill>
+                <a:latin typeface="Arial" pitchFamily="34" charset="0"/>
+                <a:ea typeface="Arial" pitchFamily="34" charset="-122"/>
+                <a:cs typeface="Arial" pitchFamily="34" charset="-120"/>
+              </a:rPr>
+              <a:t>PPP ACTIVE</a:t>
+            </a:r>
+            <a:endParaRPr lang="en-US" sz="1200" dirty="0"/>
+          </a:p>
+        </p:txBody>
+      </p:sp>
+      <p:sp>
+        <p:nvSpPr>
+          <p:cNvPr id="53" name="Text 51"/>
+          <p:cNvSpPr/>
+          <p:nvPr/>
+        </p:nvSpPr>
+        <p:spPr>
+          <a:xfrm>
+            <a:off x="5257800" y="3108960"/>
+            <a:ext cx="2286000" cy="182880"/>
+          </a:xfrm>
+          <a:prstGeom prst="rect">
+            <a:avLst/>
+          </a:prstGeom>
+          <a:noFill/>
+          <a:ln/>
+        </p:spPr>
+        <p:txBody>
+          <a:bodyPr wrap="square" rtlCol="0" anchor="t"/>
+          <a:lstStyle/>
+          <a:p>
+            <a:pPr algn="l" indent="0" marL="0">
+              <a:buNone/>
+            </a:pPr>
+            <a:r>
+              <a:rPr lang="en-US" sz="1100" dirty="0">
+                <a:solidFill>
+                  <a:srgbClr val="60758A"/>
+                </a:solidFill>
+                <a:latin typeface="Arial" pitchFamily="34" charset="0"/>
+                <a:ea typeface="Arial" pitchFamily="34" charset="-122"/>
+                <a:cs typeface="Arial" pitchFamily="34" charset="-120"/>
+              </a:rPr>
+              <a:t>4/9 milestones</a:t>
+            </a:r>
+            <a:endParaRPr lang="en-US" sz="1100" dirty="0"/>
+          </a:p>
+        </p:txBody>
+      </p:sp>
+      <p:sp>
+        <p:nvSpPr>
+          <p:cNvPr id="54" name="Shape 52"/>
+          <p:cNvSpPr/>
+          <p:nvPr/>
+        </p:nvSpPr>
+        <p:spPr>
+          <a:xfrm>
+            <a:off x="2176272" y="3794760"/>
+            <a:ext cx="8833104" cy="137160"/>
+          </a:xfrm>
+          <a:prstGeom prst="rect">
+            <a:avLst/>
+          </a:prstGeom>
+          <a:solidFill>
+            <a:srgbClr val="EEF2F5"/>
+          </a:solidFill>
+          <a:ln/>
+        </p:spPr>
+      </p:sp>
+      <p:sp>
+        <p:nvSpPr>
+          <p:cNvPr id="55" name="Text 53"/>
+          <p:cNvSpPr/>
+          <p:nvPr/>
+        </p:nvSpPr>
+        <p:spPr>
+          <a:xfrm>
+            <a:off x="457200" y="3566160"/>
+            <a:ext cx="1956816" cy="228600"/>
+          </a:xfrm>
+          <a:prstGeom prst="rect">
+            <a:avLst/>
+          </a:prstGeom>
+          <a:noFill/>
+          <a:ln/>
+        </p:spPr>
+        <p:txBody>
+          <a:bodyPr wrap="square" rtlCol="0" anchor="t"/>
+          <a:lstStyle/>
+          <a:p>
+            <a:pPr algn="l" indent="0" marL="0">
+              <a:buNone/>
+            </a:pPr>
+            <a:r>
+              <a:rPr lang="en-US" sz="1300" b="1" dirty="0">
+                <a:solidFill>
+                  <a:srgbClr val="08264C"/>
+                </a:solidFill>
+                <a:latin typeface="Arial" pitchFamily="34" charset="0"/>
+                <a:ea typeface="Arial" pitchFamily="34" charset="-122"/>
+                <a:cs typeface="Arial" pitchFamily="34" charset="-120"/>
+              </a:rPr>
               <a:t>EASTBAY PH-2 TP</a:t>
             </a:r>
             <a:endParaRPr lang="en-US" sz="1300" dirty="0"/>
@@ -6780,13 +7036,13 @@
       </p:sp>
       <p:sp>
         <p:nvSpPr>
-          <p:cNvPr id="47" name="Text 45"/>
-          <p:cNvSpPr/>
-          <p:nvPr/>
-        </p:nvSpPr>
-        <p:spPr>
-          <a:xfrm>
-            <a:off x="457200" y="2953512"/>
+          <p:cNvPr id="56" name="Text 54"/>
+          <p:cNvSpPr/>
+          <p:nvPr/>
+        </p:nvSpPr>
+        <p:spPr>
+          <a:xfrm>
+            <a:off x="457200" y="3822192"/>
             <a:ext cx="2002536" cy="182880"/>
           </a:xfrm>
           <a:prstGeom prst="rect">
@@ -6819,13 +7075,13 @@
       </p:sp>
       <p:sp>
         <p:nvSpPr>
-          <p:cNvPr id="48" name="Shape 46"/>
-          <p:cNvSpPr/>
-          <p:nvPr/>
-        </p:nvSpPr>
-        <p:spPr>
-          <a:xfrm>
-            <a:off x="5538216" y="2880360"/>
+          <p:cNvPr id="57" name="Shape 55"/>
+          <p:cNvSpPr/>
+          <p:nvPr/>
+        </p:nvSpPr>
+        <p:spPr>
+          <a:xfrm>
+            <a:off x="5538216" y="3749040"/>
             <a:ext cx="146304" cy="228600"/>
           </a:xfrm>
           <a:prstGeom prst="rect">
@@ -6839,13 +7095,13 @@
       </p:sp>
       <p:sp>
         <p:nvSpPr>
-          <p:cNvPr id="49" name="Shape 47"/>
-          <p:cNvSpPr/>
-          <p:nvPr/>
-        </p:nvSpPr>
-        <p:spPr>
-          <a:xfrm>
-            <a:off x="8482584" y="2880360"/>
+          <p:cNvPr id="58" name="Shape 56"/>
+          <p:cNvSpPr/>
+          <p:nvPr/>
+        </p:nvSpPr>
+        <p:spPr>
+          <a:xfrm>
+            <a:off x="8482584" y="3749040"/>
             <a:ext cx="146304" cy="228600"/>
           </a:xfrm>
           <a:prstGeom prst="rect">
@@ -6859,13 +7115,13 @@
       </p:sp>
       <p:sp>
         <p:nvSpPr>
-          <p:cNvPr id="50" name="Shape 48"/>
-          <p:cNvSpPr/>
-          <p:nvPr/>
-        </p:nvSpPr>
-        <p:spPr>
-          <a:xfrm>
-            <a:off x="5611368" y="2926080"/>
+          <p:cNvPr id="59" name="Shape 57"/>
+          <p:cNvSpPr/>
+          <p:nvPr/>
+        </p:nvSpPr>
+        <p:spPr>
+          <a:xfrm>
+            <a:off x="5611368" y="3794760"/>
             <a:ext cx="2944368" cy="137160"/>
           </a:xfrm>
           <a:prstGeom prst="rect">
@@ -6879,13 +7135,13 @@
       </p:sp>
       <p:sp>
         <p:nvSpPr>
-          <p:cNvPr id="51" name="Text 49"/>
-          <p:cNvSpPr/>
-          <p:nvPr/>
-        </p:nvSpPr>
-        <p:spPr>
-          <a:xfrm>
-            <a:off x="5257800" y="2880360"/>
+          <p:cNvPr id="60" name="Text 58"/>
+          <p:cNvSpPr/>
+          <p:nvPr/>
+        </p:nvSpPr>
+        <p:spPr>
+          <a:xfrm>
+            <a:off x="5257800" y="3749040"/>
             <a:ext cx="2286000" cy="228600"/>
           </a:xfrm>
           <a:prstGeom prst="rect">
@@ -6918,13 +7174,13 @@
       </p:sp>
       <p:sp>
         <p:nvSpPr>
-          <p:cNvPr id="52" name="Text 50"/>
-          <p:cNvSpPr/>
-          <p:nvPr/>
-        </p:nvSpPr>
-        <p:spPr>
-          <a:xfrm>
-            <a:off x="5257800" y="3108960"/>
+          <p:cNvPr id="61" name="Text 59"/>
+          <p:cNvSpPr/>
+          <p:nvPr/>
+        </p:nvSpPr>
+        <p:spPr>
+          <a:xfrm>
+            <a:off x="5257800" y="3977640"/>
             <a:ext cx="2286000" cy="182880"/>
           </a:xfrm>
           <a:prstGeom prst="rect">
@@ -6950,262 +7206,6 @@
                 <a:cs typeface="Arial" pitchFamily="34" charset="-120"/>
               </a:rPr>
               <a:t>3/9 milestones</a:t>
-            </a:r>
-            <a:endParaRPr lang="en-US" sz="1100" dirty="0"/>
-          </a:p>
-        </p:txBody>
-      </p:sp>
-      <p:sp>
-        <p:nvSpPr>
-          <p:cNvPr id="53" name="Shape 51"/>
-          <p:cNvSpPr/>
-          <p:nvPr/>
-        </p:nvSpPr>
-        <p:spPr>
-          <a:xfrm>
-            <a:off x="2176272" y="3794760"/>
-            <a:ext cx="8833104" cy="137160"/>
-          </a:xfrm>
-          <a:prstGeom prst="rect">
-            <a:avLst/>
-          </a:prstGeom>
-          <a:solidFill>
-            <a:srgbClr val="EEF2F5"/>
-          </a:solidFill>
-          <a:ln/>
-        </p:spPr>
-      </p:sp>
-      <p:sp>
-        <p:nvSpPr>
-          <p:cNvPr id="54" name="Text 52"/>
-          <p:cNvSpPr/>
-          <p:nvPr/>
-        </p:nvSpPr>
-        <p:spPr>
-          <a:xfrm>
-            <a:off x="457200" y="3566160"/>
-            <a:ext cx="1956816" cy="228600"/>
-          </a:xfrm>
-          <a:prstGeom prst="rect">
-            <a:avLst/>
-          </a:prstGeom>
-          <a:noFill/>
-          <a:ln/>
-        </p:spPr>
-        <p:txBody>
-          <a:bodyPr wrap="square" rtlCol="0" anchor="t"/>
-          <a:lstStyle/>
-          <a:p>
-            <a:pPr algn="l" indent="0" marL="0">
-              <a:buNone/>
-            </a:pPr>
-            <a:r>
-              <a:rPr lang="en-US" sz="1300" b="1" dirty="0">
-                <a:solidFill>
-                  <a:srgbClr val="08264C"/>
-                </a:solidFill>
-                <a:latin typeface="Arial" pitchFamily="34" charset="0"/>
-                <a:ea typeface="Arial" pitchFamily="34" charset="-122"/>
-                <a:cs typeface="Arial" pitchFamily="34" charset="-120"/>
-              </a:rPr>
-              <a:t>HTT STP</a:t>
-            </a:r>
-            <a:endParaRPr lang="en-US" sz="1300" dirty="0"/>
-          </a:p>
-        </p:txBody>
-      </p:sp>
-      <p:sp>
-        <p:nvSpPr>
-          <p:cNvPr id="55" name="Text 53"/>
-          <p:cNvSpPr/>
-          <p:nvPr/>
-        </p:nvSpPr>
-        <p:spPr>
-          <a:xfrm>
-            <a:off x="457200" y="3822192"/>
-            <a:ext cx="2002536" cy="182880"/>
-          </a:xfrm>
-          <a:prstGeom prst="rect">
-            <a:avLst/>
-          </a:prstGeom>
-          <a:noFill/>
-          <a:ln/>
-        </p:spPr>
-        <p:txBody>
-          <a:bodyPr wrap="square" rtlCol="0" anchor="t"/>
-          <a:lstStyle/>
-          <a:p>
-            <a:pPr algn="l" indent="0" marL="0">
-              <a:buNone/>
-            </a:pPr>
-            <a:r>
-              <a:rPr lang="en-US" sz="1200" dirty="0">
-                <a:solidFill>
-                  <a:srgbClr val="60758A"/>
-                </a:solidFill>
-                <a:latin typeface="Arial" pitchFamily="34" charset="0"/>
-                <a:ea typeface="Arial" pitchFamily="34" charset="-122"/>
-                <a:cs typeface="Arial" pitchFamily="34" charset="-120"/>
-              </a:rPr>
-              <a:t>PPP: MAR 2026</a:t>
-            </a:r>
-            <a:endParaRPr lang="en-US" sz="1200" dirty="0"/>
-          </a:p>
-        </p:txBody>
-      </p:sp>
-      <p:sp>
-        <p:nvSpPr>
-          <p:cNvPr id="56" name="Shape 54"/>
-          <p:cNvSpPr/>
-          <p:nvPr/>
-        </p:nvSpPr>
-        <p:spPr>
-          <a:xfrm>
-            <a:off x="4066032" y="3749040"/>
-            <a:ext cx="146304" cy="228600"/>
-          </a:xfrm>
-          <a:prstGeom prst="rect">
-            <a:avLst/>
-          </a:prstGeom>
-          <a:solidFill>
-            <a:srgbClr val="08264C"/>
-          </a:solidFill>
-          <a:ln/>
-        </p:spPr>
-      </p:sp>
-      <p:sp>
-        <p:nvSpPr>
-          <p:cNvPr id="57" name="Shape 55"/>
-          <p:cNvSpPr/>
-          <p:nvPr/>
-        </p:nvSpPr>
-        <p:spPr>
-          <a:xfrm>
-            <a:off x="7010400" y="3749040"/>
-            <a:ext cx="146304" cy="228600"/>
-          </a:xfrm>
-          <a:prstGeom prst="rect">
-            <a:avLst/>
-          </a:prstGeom>
-          <a:solidFill>
-            <a:srgbClr val="08264C"/>
-          </a:solidFill>
-          <a:ln/>
-        </p:spPr>
-      </p:sp>
-      <p:sp>
-        <p:nvSpPr>
-          <p:cNvPr id="58" name="Shape 56"/>
-          <p:cNvSpPr/>
-          <p:nvPr/>
-        </p:nvSpPr>
-        <p:spPr>
-          <a:xfrm>
-            <a:off x="4139184" y="3794760"/>
-            <a:ext cx="981456" cy="137160"/>
-          </a:xfrm>
-          <a:prstGeom prst="rect">
-            <a:avLst/>
-          </a:prstGeom>
-          <a:solidFill>
-            <a:srgbClr val="00A9C5"/>
-          </a:solidFill>
-          <a:ln/>
-        </p:spPr>
-      </p:sp>
-      <p:sp>
-        <p:nvSpPr>
-          <p:cNvPr id="59" name="Shape 57"/>
-          <p:cNvSpPr/>
-          <p:nvPr/>
-        </p:nvSpPr>
-        <p:spPr>
-          <a:xfrm>
-            <a:off x="5120640" y="3794760"/>
-            <a:ext cx="1962912" cy="137160"/>
-          </a:xfrm>
-          <a:prstGeom prst="rect">
-            <a:avLst/>
-          </a:prstGeom>
-          <a:solidFill>
-            <a:srgbClr val="A8D5E5"/>
-          </a:solidFill>
-          <a:ln/>
-        </p:spPr>
-      </p:sp>
-      <p:sp>
-        <p:nvSpPr>
-          <p:cNvPr id="60" name="Text 58"/>
-          <p:cNvSpPr/>
-          <p:nvPr/>
-        </p:nvSpPr>
-        <p:spPr>
-          <a:xfrm>
-            <a:off x="5257800" y="3749040"/>
-            <a:ext cx="2286000" cy="228600"/>
-          </a:xfrm>
-          <a:prstGeom prst="rect">
-            <a:avLst/>
-          </a:prstGeom>
-          <a:noFill/>
-          <a:ln/>
-        </p:spPr>
-        <p:txBody>
-          <a:bodyPr wrap="square" rtlCol="0" anchor="t"/>
-          <a:lstStyle/>
-          <a:p>
-            <a:pPr algn="l" indent="0" marL="0">
-              <a:buNone/>
-            </a:pPr>
-            <a:r>
-              <a:rPr lang="en-US" sz="1200" b="1" dirty="0">
-                <a:solidFill>
-                  <a:srgbClr val="00A9C5"/>
-                </a:solidFill>
-                <a:latin typeface="Arial" pitchFamily="34" charset="0"/>
-                <a:ea typeface="Arial" pitchFamily="34" charset="-122"/>
-                <a:cs typeface="Arial" pitchFamily="34" charset="-120"/>
-              </a:rPr>
-              <a:t>PPP ACTIVE</a:t>
-            </a:r>
-            <a:endParaRPr lang="en-US" sz="1200" dirty="0"/>
-          </a:p>
-        </p:txBody>
-      </p:sp>
-      <p:sp>
-        <p:nvSpPr>
-          <p:cNvPr id="61" name="Text 59"/>
-          <p:cNvSpPr/>
-          <p:nvPr/>
-        </p:nvSpPr>
-        <p:spPr>
-          <a:xfrm>
-            <a:off x="5257800" y="3977640"/>
-            <a:ext cx="2286000" cy="182880"/>
-          </a:xfrm>
-          <a:prstGeom prst="rect">
-            <a:avLst/>
-          </a:prstGeom>
-          <a:noFill/>
-          <a:ln/>
-        </p:spPr>
-        <p:txBody>
-          <a:bodyPr wrap="square" rtlCol="0" anchor="t"/>
-          <a:lstStyle/>
-          <a:p>
-            <a:pPr algn="l" indent="0" marL="0">
-              <a:buNone/>
-            </a:pPr>
-            <a:r>
-              <a:rPr lang="en-US" sz="1100" dirty="0">
-                <a:solidFill>
-                  <a:srgbClr val="60758A"/>
-                </a:solidFill>
-                <a:latin typeface="Arial" pitchFamily="34" charset="0"/>
-                <a:ea typeface="Arial" pitchFamily="34" charset="-122"/>
-                <a:cs typeface="Arial" pitchFamily="34" charset="-120"/>
-              </a:rPr>
-              <a:t>4/9 milestones</a:t>
             </a:r>
             <a:endParaRPr lang="en-US" sz="1100" dirty="0"/>
           </a:p>
@@ -7977,6 +7977,315 @@
                 <a:ea typeface="Arial" pitchFamily="34" charset="-122"/>
                 <a:cs typeface="Arial" pitchFamily="34" charset="-120"/>
               </a:rPr>
+              <a:t>AGLIPAY STP</a:t>
+            </a:r>
+            <a:endParaRPr lang="en-US" sz="900" dirty="0"/>
+          </a:p>
+        </p:txBody>
+      </p:sp>
+      <p:sp>
+        <p:nvSpPr>
+          <p:cNvPr id="13" name="Text 11"/>
+          <p:cNvSpPr/>
+          <p:nvPr/>
+        </p:nvSpPr>
+        <p:spPr>
+          <a:xfrm>
+            <a:off x="585216" y="4023360"/>
+            <a:ext cx="1636776" cy="201168"/>
+          </a:xfrm>
+          <a:prstGeom prst="rect">
+            <a:avLst/>
+          </a:prstGeom>
+          <a:noFill/>
+          <a:ln/>
+        </p:spPr>
+        <p:txBody>
+          <a:bodyPr wrap="square" rtlCol="0" anchor="t"/>
+          <a:lstStyle/>
+          <a:p>
+            <a:pPr algn="l" indent="0" marL="0">
+              <a:buNone/>
+            </a:pPr>
+            <a:r>
+              <a:rPr lang="en-US" sz="1600" b="1" dirty="0">
+                <a:solidFill>
+                  <a:srgbClr val="17324F"/>
+                </a:solidFill>
+                <a:latin typeface="Arial" pitchFamily="34" charset="0"/>
+                <a:ea typeface="Arial" pitchFamily="34" charset="-122"/>
+                <a:cs typeface="Arial" pitchFamily="34" charset="-120"/>
+              </a:rPr>
+              <a:t>21%</a:t>
+            </a:r>
+            <a:endParaRPr lang="en-US" sz="1600" dirty="0"/>
+          </a:p>
+        </p:txBody>
+      </p:sp>
+      <p:sp>
+        <p:nvSpPr>
+          <p:cNvPr id="14" name="Shape 12"/>
+          <p:cNvSpPr/>
+          <p:nvPr/>
+        </p:nvSpPr>
+        <p:spPr>
+          <a:xfrm>
+            <a:off x="2350008" y="3749040"/>
+            <a:ext cx="1783080" cy="548640"/>
+          </a:xfrm>
+          <a:prstGeom prst="rect">
+            <a:avLst/>
+          </a:prstGeom>
+          <a:solidFill>
+            <a:srgbClr val="DFF3EC"/>
+          </a:solidFill>
+          <a:ln w="12700">
+            <a:solidFill>
+              <a:srgbClr val="D3DEE8"/>
+            </a:solidFill>
+            <a:prstDash val="solid"/>
+          </a:ln>
+        </p:spPr>
+      </p:sp>
+      <p:sp>
+        <p:nvSpPr>
+          <p:cNvPr id="15" name="Text 13"/>
+          <p:cNvSpPr/>
+          <p:nvPr/>
+        </p:nvSpPr>
+        <p:spPr>
+          <a:xfrm>
+            <a:off x="2404872" y="3803904"/>
+            <a:ext cx="1673352" cy="182880"/>
+          </a:xfrm>
+          <a:prstGeom prst="rect">
+            <a:avLst/>
+          </a:prstGeom>
+          <a:noFill/>
+          <a:ln/>
+        </p:spPr>
+        <p:txBody>
+          <a:bodyPr wrap="square" rtlCol="0" anchor="t"/>
+          <a:lstStyle/>
+          <a:p>
+            <a:pPr algn="l" indent="0" marL="0">
+              <a:buNone/>
+            </a:pPr>
+            <a:r>
+              <a:rPr lang="en-US" sz="900" b="1" dirty="0">
+                <a:solidFill>
+                  <a:srgbClr val="17324F"/>
+                </a:solidFill>
+                <a:latin typeface="Arial" pitchFamily="34" charset="0"/>
+                <a:ea typeface="Arial" pitchFamily="34" charset="-122"/>
+                <a:cs typeface="Arial" pitchFamily="34" charset="-120"/>
+              </a:rPr>
+              <a:t>HTT STP</a:t>
+            </a:r>
+            <a:endParaRPr lang="en-US" sz="900" dirty="0"/>
+          </a:p>
+        </p:txBody>
+      </p:sp>
+      <p:sp>
+        <p:nvSpPr>
+          <p:cNvPr id="16" name="Text 14"/>
+          <p:cNvSpPr/>
+          <p:nvPr/>
+        </p:nvSpPr>
+        <p:spPr>
+          <a:xfrm>
+            <a:off x="2423160" y="4023360"/>
+            <a:ext cx="1636776" cy="201168"/>
+          </a:xfrm>
+          <a:prstGeom prst="rect">
+            <a:avLst/>
+          </a:prstGeom>
+          <a:noFill/>
+          <a:ln/>
+        </p:spPr>
+        <p:txBody>
+          <a:bodyPr wrap="square" rtlCol="0" anchor="t"/>
+          <a:lstStyle/>
+          <a:p>
+            <a:pPr algn="l" indent="0" marL="0">
+              <a:buNone/>
+            </a:pPr>
+            <a:r>
+              <a:rPr lang="en-US" sz="1600" b="1" dirty="0">
+                <a:solidFill>
+                  <a:srgbClr val="17324F"/>
+                </a:solidFill>
+                <a:latin typeface="Arial" pitchFamily="34" charset="0"/>
+                <a:ea typeface="Arial" pitchFamily="34" charset="-122"/>
+                <a:cs typeface="Arial" pitchFamily="34" charset="-120"/>
+              </a:rPr>
+              <a:t>79%</a:t>
+            </a:r>
+            <a:endParaRPr lang="en-US" sz="1600" dirty="0"/>
+          </a:p>
+        </p:txBody>
+      </p:sp>
+      <p:sp>
+        <p:nvSpPr>
+          <p:cNvPr id="17" name="Shape 15"/>
+          <p:cNvSpPr/>
+          <p:nvPr/>
+        </p:nvSpPr>
+        <p:spPr>
+          <a:xfrm>
+            <a:off x="512064" y="4352544"/>
+            <a:ext cx="1783080" cy="548640"/>
+          </a:xfrm>
+          <a:prstGeom prst="rect">
+            <a:avLst/>
+          </a:prstGeom>
+          <a:solidFill>
+            <a:srgbClr val="FFF6DF"/>
+          </a:solidFill>
+          <a:ln w="12700">
+            <a:solidFill>
+              <a:srgbClr val="D3DEE8"/>
+            </a:solidFill>
+            <a:prstDash val="solid"/>
+          </a:ln>
+        </p:spPr>
+      </p:sp>
+      <p:sp>
+        <p:nvSpPr>
+          <p:cNvPr id="18" name="Text 16"/>
+          <p:cNvSpPr/>
+          <p:nvPr/>
+        </p:nvSpPr>
+        <p:spPr>
+          <a:xfrm>
+            <a:off x="566928" y="4407408"/>
+            <a:ext cx="1673352" cy="182880"/>
+          </a:xfrm>
+          <a:prstGeom prst="rect">
+            <a:avLst/>
+          </a:prstGeom>
+          <a:noFill/>
+          <a:ln/>
+        </p:spPr>
+        <p:txBody>
+          <a:bodyPr wrap="square" rtlCol="0" anchor="t"/>
+          <a:lstStyle/>
+          <a:p>
+            <a:pPr algn="l" indent="0" marL="0">
+              <a:buNone/>
+            </a:pPr>
+            <a:r>
+              <a:rPr lang="en-US" sz="900" b="1" dirty="0">
+                <a:solidFill>
+                  <a:srgbClr val="17324F"/>
+                </a:solidFill>
+                <a:latin typeface="Arial" pitchFamily="34" charset="0"/>
+                <a:ea typeface="Arial" pitchFamily="34" charset="-122"/>
+                <a:cs typeface="Arial" pitchFamily="34" charset="-120"/>
+              </a:rPr>
+              <a:t>EASTBAY PH-2 TP</a:t>
+            </a:r>
+            <a:endParaRPr lang="en-US" sz="900" dirty="0"/>
+          </a:p>
+        </p:txBody>
+      </p:sp>
+      <p:sp>
+        <p:nvSpPr>
+          <p:cNvPr id="19" name="Text 17"/>
+          <p:cNvSpPr/>
+          <p:nvPr/>
+        </p:nvSpPr>
+        <p:spPr>
+          <a:xfrm>
+            <a:off x="585216" y="4626864"/>
+            <a:ext cx="1636776" cy="201168"/>
+          </a:xfrm>
+          <a:prstGeom prst="rect">
+            <a:avLst/>
+          </a:prstGeom>
+          <a:noFill/>
+          <a:ln/>
+        </p:spPr>
+        <p:txBody>
+          <a:bodyPr wrap="square" rtlCol="0" anchor="t"/>
+          <a:lstStyle/>
+          <a:p>
+            <a:pPr algn="l" indent="0" marL="0">
+              <a:buNone/>
+            </a:pPr>
+            <a:r>
+              <a:rPr lang="en-US" sz="1600" b="1" dirty="0">
+                <a:solidFill>
+                  <a:srgbClr val="17324F"/>
+                </a:solidFill>
+                <a:latin typeface="Arial" pitchFamily="34" charset="0"/>
+                <a:ea typeface="Arial" pitchFamily="34" charset="-122"/>
+                <a:cs typeface="Arial" pitchFamily="34" charset="-120"/>
+              </a:rPr>
+              <a:t>29%</a:t>
+            </a:r>
+            <a:endParaRPr lang="en-US" sz="1600" dirty="0"/>
+          </a:p>
+        </p:txBody>
+      </p:sp>
+      <p:sp>
+        <p:nvSpPr>
+          <p:cNvPr id="20" name="Shape 18"/>
+          <p:cNvSpPr/>
+          <p:nvPr/>
+        </p:nvSpPr>
+        <p:spPr>
+          <a:xfrm>
+            <a:off x="2350008" y="4352544"/>
+            <a:ext cx="1783080" cy="548640"/>
+          </a:xfrm>
+          <a:prstGeom prst="rect">
+            <a:avLst/>
+          </a:prstGeom>
+          <a:solidFill>
+            <a:srgbClr val="FFF6DF"/>
+          </a:solidFill>
+          <a:ln w="12700">
+            <a:solidFill>
+              <a:srgbClr val="D3DEE8"/>
+            </a:solidFill>
+            <a:prstDash val="solid"/>
+          </a:ln>
+        </p:spPr>
+      </p:sp>
+      <p:sp>
+        <p:nvSpPr>
+          <p:cNvPr id="21" name="Text 19"/>
+          <p:cNvSpPr/>
+          <p:nvPr/>
+        </p:nvSpPr>
+        <p:spPr>
+          <a:xfrm>
+            <a:off x="2404872" y="4407408"/>
+            <a:ext cx="1673352" cy="182880"/>
+          </a:xfrm>
+          <a:prstGeom prst="rect">
+            <a:avLst/>
+          </a:prstGeom>
+          <a:noFill/>
+          <a:ln/>
+        </p:spPr>
+        <p:txBody>
+          <a:bodyPr wrap="square" rtlCol="0" anchor="t"/>
+          <a:lstStyle/>
+          <a:p>
+            <a:pPr algn="l" indent="0" marL="0">
+              <a:buNone/>
+            </a:pPr>
+            <a:r>
+              <a:rPr lang="en-US" sz="900" b="1" dirty="0">
+                <a:solidFill>
+                  <a:srgbClr val="17324F"/>
+                </a:solidFill>
+                <a:latin typeface="Arial" pitchFamily="34" charset="0"/>
+                <a:ea typeface="Arial" pitchFamily="34" charset="-122"/>
+                <a:cs typeface="Arial" pitchFamily="34" charset="-120"/>
+              </a:rPr>
               <a:t>KAYSAKAT TP</a:t>
             </a:r>
             <a:endParaRPr lang="en-US" sz="900" dirty="0"/>
@@ -7985,13 +8294,13 @@
       </p:sp>
       <p:sp>
         <p:nvSpPr>
-          <p:cNvPr id="13" name="Text 11"/>
-          <p:cNvSpPr/>
-          <p:nvPr/>
-        </p:nvSpPr>
-        <p:spPr>
-          <a:xfrm>
-            <a:off x="585216" y="4023360"/>
+          <p:cNvPr id="22" name="Text 20"/>
+          <p:cNvSpPr/>
+          <p:nvPr/>
+        </p:nvSpPr>
+        <p:spPr>
+          <a:xfrm>
+            <a:off x="2423160" y="4626864"/>
             <a:ext cx="1636776" cy="201168"/>
           </a:xfrm>
           <a:prstGeom prst="rect">
@@ -8017,315 +8326,6 @@
                 <a:cs typeface="Arial" pitchFamily="34" charset="-120"/>
               </a:rPr>
               <a:t>7%</a:t>
-            </a:r>
-            <a:endParaRPr lang="en-US" sz="1600" dirty="0"/>
-          </a:p>
-        </p:txBody>
-      </p:sp>
-      <p:sp>
-        <p:nvSpPr>
-          <p:cNvPr id="14" name="Shape 12"/>
-          <p:cNvSpPr/>
-          <p:nvPr/>
-        </p:nvSpPr>
-        <p:spPr>
-          <a:xfrm>
-            <a:off x="2350008" y="3749040"/>
-            <a:ext cx="1783080" cy="548640"/>
-          </a:xfrm>
-          <a:prstGeom prst="rect">
-            <a:avLst/>
-          </a:prstGeom>
-          <a:solidFill>
-            <a:srgbClr val="FFF6DF"/>
-          </a:solidFill>
-          <a:ln w="12700">
-            <a:solidFill>
-              <a:srgbClr val="D3DEE8"/>
-            </a:solidFill>
-            <a:prstDash val="solid"/>
-          </a:ln>
-        </p:spPr>
-      </p:sp>
-      <p:sp>
-        <p:nvSpPr>
-          <p:cNvPr id="15" name="Text 13"/>
-          <p:cNvSpPr/>
-          <p:nvPr/>
-        </p:nvSpPr>
-        <p:spPr>
-          <a:xfrm>
-            <a:off x="2404872" y="3803904"/>
-            <a:ext cx="1673352" cy="182880"/>
-          </a:xfrm>
-          <a:prstGeom prst="rect">
-            <a:avLst/>
-          </a:prstGeom>
-          <a:noFill/>
-          <a:ln/>
-        </p:spPr>
-        <p:txBody>
-          <a:bodyPr wrap="square" rtlCol="0" anchor="t"/>
-          <a:lstStyle/>
-          <a:p>
-            <a:pPr algn="l" indent="0" marL="0">
-              <a:buNone/>
-            </a:pPr>
-            <a:r>
-              <a:rPr lang="en-US" sz="900" b="1" dirty="0">
-                <a:solidFill>
-                  <a:srgbClr val="17324F"/>
-                </a:solidFill>
-                <a:latin typeface="Arial" pitchFamily="34" charset="0"/>
-                <a:ea typeface="Arial" pitchFamily="34" charset="-122"/>
-                <a:cs typeface="Arial" pitchFamily="34" charset="-120"/>
-              </a:rPr>
-              <a:t>AGLIPAY STP</a:t>
-            </a:r>
-            <a:endParaRPr lang="en-US" sz="900" dirty="0"/>
-          </a:p>
-        </p:txBody>
-      </p:sp>
-      <p:sp>
-        <p:nvSpPr>
-          <p:cNvPr id="16" name="Text 14"/>
-          <p:cNvSpPr/>
-          <p:nvPr/>
-        </p:nvSpPr>
-        <p:spPr>
-          <a:xfrm>
-            <a:off x="2423160" y="4023360"/>
-            <a:ext cx="1636776" cy="201168"/>
-          </a:xfrm>
-          <a:prstGeom prst="rect">
-            <a:avLst/>
-          </a:prstGeom>
-          <a:noFill/>
-          <a:ln/>
-        </p:spPr>
-        <p:txBody>
-          <a:bodyPr wrap="square" rtlCol="0" anchor="t"/>
-          <a:lstStyle/>
-          <a:p>
-            <a:pPr algn="l" indent="0" marL="0">
-              <a:buNone/>
-            </a:pPr>
-            <a:r>
-              <a:rPr lang="en-US" sz="1600" b="1" dirty="0">
-                <a:solidFill>
-                  <a:srgbClr val="17324F"/>
-                </a:solidFill>
-                <a:latin typeface="Arial" pitchFamily="34" charset="0"/>
-                <a:ea typeface="Arial" pitchFamily="34" charset="-122"/>
-                <a:cs typeface="Arial" pitchFamily="34" charset="-120"/>
-              </a:rPr>
-              <a:t>21%</a:t>
-            </a:r>
-            <a:endParaRPr lang="en-US" sz="1600" dirty="0"/>
-          </a:p>
-        </p:txBody>
-      </p:sp>
-      <p:sp>
-        <p:nvSpPr>
-          <p:cNvPr id="17" name="Shape 15"/>
-          <p:cNvSpPr/>
-          <p:nvPr/>
-        </p:nvSpPr>
-        <p:spPr>
-          <a:xfrm>
-            <a:off x="512064" y="4352544"/>
-            <a:ext cx="1783080" cy="548640"/>
-          </a:xfrm>
-          <a:prstGeom prst="rect">
-            <a:avLst/>
-          </a:prstGeom>
-          <a:solidFill>
-            <a:srgbClr val="FFF6DF"/>
-          </a:solidFill>
-          <a:ln w="12700">
-            <a:solidFill>
-              <a:srgbClr val="D3DEE8"/>
-            </a:solidFill>
-            <a:prstDash val="solid"/>
-          </a:ln>
-        </p:spPr>
-      </p:sp>
-      <p:sp>
-        <p:nvSpPr>
-          <p:cNvPr id="18" name="Text 16"/>
-          <p:cNvSpPr/>
-          <p:nvPr/>
-        </p:nvSpPr>
-        <p:spPr>
-          <a:xfrm>
-            <a:off x="566928" y="4407408"/>
-            <a:ext cx="1673352" cy="182880"/>
-          </a:xfrm>
-          <a:prstGeom prst="rect">
-            <a:avLst/>
-          </a:prstGeom>
-          <a:noFill/>
-          <a:ln/>
-        </p:spPr>
-        <p:txBody>
-          <a:bodyPr wrap="square" rtlCol="0" anchor="t"/>
-          <a:lstStyle/>
-          <a:p>
-            <a:pPr algn="l" indent="0" marL="0">
-              <a:buNone/>
-            </a:pPr>
-            <a:r>
-              <a:rPr lang="en-US" sz="900" b="1" dirty="0">
-                <a:solidFill>
-                  <a:srgbClr val="17324F"/>
-                </a:solidFill>
-                <a:latin typeface="Arial" pitchFamily="34" charset="0"/>
-                <a:ea typeface="Arial" pitchFamily="34" charset="-122"/>
-                <a:cs typeface="Arial" pitchFamily="34" charset="-120"/>
-              </a:rPr>
-              <a:t>EASTBAY PH-2 TP</a:t>
-            </a:r>
-            <a:endParaRPr lang="en-US" sz="900" dirty="0"/>
-          </a:p>
-        </p:txBody>
-      </p:sp>
-      <p:sp>
-        <p:nvSpPr>
-          <p:cNvPr id="19" name="Text 17"/>
-          <p:cNvSpPr/>
-          <p:nvPr/>
-        </p:nvSpPr>
-        <p:spPr>
-          <a:xfrm>
-            <a:off x="585216" y="4626864"/>
-            <a:ext cx="1636776" cy="201168"/>
-          </a:xfrm>
-          <a:prstGeom prst="rect">
-            <a:avLst/>
-          </a:prstGeom>
-          <a:noFill/>
-          <a:ln/>
-        </p:spPr>
-        <p:txBody>
-          <a:bodyPr wrap="square" rtlCol="0" anchor="t"/>
-          <a:lstStyle/>
-          <a:p>
-            <a:pPr algn="l" indent="0" marL="0">
-              <a:buNone/>
-            </a:pPr>
-            <a:r>
-              <a:rPr lang="en-US" sz="1600" b="1" dirty="0">
-                <a:solidFill>
-                  <a:srgbClr val="17324F"/>
-                </a:solidFill>
-                <a:latin typeface="Arial" pitchFamily="34" charset="0"/>
-                <a:ea typeface="Arial" pitchFamily="34" charset="-122"/>
-                <a:cs typeface="Arial" pitchFamily="34" charset="-120"/>
-              </a:rPr>
-              <a:t>29%</a:t>
-            </a:r>
-            <a:endParaRPr lang="en-US" sz="1600" dirty="0"/>
-          </a:p>
-        </p:txBody>
-      </p:sp>
-      <p:sp>
-        <p:nvSpPr>
-          <p:cNvPr id="20" name="Shape 18"/>
-          <p:cNvSpPr/>
-          <p:nvPr/>
-        </p:nvSpPr>
-        <p:spPr>
-          <a:xfrm>
-            <a:off x="2350008" y="4352544"/>
-            <a:ext cx="1783080" cy="548640"/>
-          </a:xfrm>
-          <a:prstGeom prst="rect">
-            <a:avLst/>
-          </a:prstGeom>
-          <a:solidFill>
-            <a:srgbClr val="DFF3EC"/>
-          </a:solidFill>
-          <a:ln w="12700">
-            <a:solidFill>
-              <a:srgbClr val="D3DEE8"/>
-            </a:solidFill>
-            <a:prstDash val="solid"/>
-          </a:ln>
-        </p:spPr>
-      </p:sp>
-      <p:sp>
-        <p:nvSpPr>
-          <p:cNvPr id="21" name="Text 19"/>
-          <p:cNvSpPr/>
-          <p:nvPr/>
-        </p:nvSpPr>
-        <p:spPr>
-          <a:xfrm>
-            <a:off x="2404872" y="4407408"/>
-            <a:ext cx="1673352" cy="182880"/>
-          </a:xfrm>
-          <a:prstGeom prst="rect">
-            <a:avLst/>
-          </a:prstGeom>
-          <a:noFill/>
-          <a:ln/>
-        </p:spPr>
-        <p:txBody>
-          <a:bodyPr wrap="square" rtlCol="0" anchor="t"/>
-          <a:lstStyle/>
-          <a:p>
-            <a:pPr algn="l" indent="0" marL="0">
-              <a:buNone/>
-            </a:pPr>
-            <a:r>
-              <a:rPr lang="en-US" sz="900" b="1" dirty="0">
-                <a:solidFill>
-                  <a:srgbClr val="17324F"/>
-                </a:solidFill>
-                <a:latin typeface="Arial" pitchFamily="34" charset="0"/>
-                <a:ea typeface="Arial" pitchFamily="34" charset="-122"/>
-                <a:cs typeface="Arial" pitchFamily="34" charset="-120"/>
-              </a:rPr>
-              <a:t>HTT STP</a:t>
-            </a:r>
-            <a:endParaRPr lang="en-US" sz="900" dirty="0"/>
-          </a:p>
-        </p:txBody>
-      </p:sp>
-      <p:sp>
-        <p:nvSpPr>
-          <p:cNvPr id="22" name="Text 20"/>
-          <p:cNvSpPr/>
-          <p:nvPr/>
-        </p:nvSpPr>
-        <p:spPr>
-          <a:xfrm>
-            <a:off x="2423160" y="4626864"/>
-            <a:ext cx="1636776" cy="201168"/>
-          </a:xfrm>
-          <a:prstGeom prst="rect">
-            <a:avLst/>
-          </a:prstGeom>
-          <a:noFill/>
-          <a:ln/>
-        </p:spPr>
-        <p:txBody>
-          <a:bodyPr wrap="square" rtlCol="0" anchor="t"/>
-          <a:lstStyle/>
-          <a:p>
-            <a:pPr algn="l" indent="0" marL="0">
-              <a:buNone/>
-            </a:pPr>
-            <a:r>
-              <a:rPr lang="en-US" sz="1600" b="1" dirty="0">
-                <a:solidFill>
-                  <a:srgbClr val="17324F"/>
-                </a:solidFill>
-                <a:latin typeface="Arial" pitchFamily="34" charset="0"/>
-                <a:ea typeface="Arial" pitchFamily="34" charset="-122"/>
-                <a:cs typeface="Arial" pitchFamily="34" charset="-120"/>
-              </a:rPr>
-              <a:t>79%</a:t>
             </a:r>
             <a:endParaRPr lang="en-US" sz="1600" dirty="0"/>
           </a:p>
@@ -8553,7 +8553,7 @@
                           <a:ea typeface="Arial" pitchFamily="34" charset="-122"/>
                           <a:cs typeface="Arial" pitchFamily="34" charset="-120"/>
                         </a:rPr>
-                        <a:t>EASTBAY PH-2 TP</a:t>
+                        <a:t>HTT STP</a:t>
                       </a:r>
                       <a:endParaRPr lang="en-US" sz="900" dirty="0">
                         <a:latin typeface="Arial" charset="0"/>
@@ -8621,7 +8621,7 @@
                           <a:ea typeface="Arial" pitchFamily="34" charset="-122"/>
                           <a:cs typeface="Arial" pitchFamily="34" charset="-120"/>
                         </a:rPr>
-                        <a:t>HTT STP</a:t>
+                        <a:t>EASTBAY PH-2 TP</a:t>
                       </a:r>
                       <a:endParaRPr lang="en-US" sz="900" dirty="0">
                         <a:latin typeface="Arial" charset="0"/>
@@ -10189,15 +10189,15 @@
                         <a:buNone/>
                       </a:pPr>
                       <a:r>
-                        <a:rPr lang="en-US" sz="1100" dirty="0">
+                        <a:rPr lang="en-US" sz="1100" b="1" dirty="0">
                           <a:solidFill>
-                            <a:srgbClr val="60758A"/>
+                            <a:srgbClr val="169873"/>
                           </a:solidFill>
                           <a:latin typeface="Arial" pitchFamily="34" charset="0"/>
                           <a:ea typeface="Arial" pitchFamily="34" charset="-122"/>
                           <a:cs typeface="Arial" pitchFamily="34" charset="-120"/>
                         </a:rPr>
-                        <a:t>—</a:t>
+                        <a:t>✓</a:t>
                       </a:r>
                       <a:endParaRPr lang="en-US" sz="1100" dirty="0">
                         <a:latin typeface="Arial" charset="0"/>
@@ -10254,15 +10254,15 @@
                         <a:buNone/>
                       </a:pPr>
                       <a:r>
-                        <a:rPr lang="en-US" sz="1100" b="1" dirty="0">
+                        <a:rPr lang="en-US" sz="1100" dirty="0">
                           <a:solidFill>
-                            <a:srgbClr val="169873"/>
+                            <a:srgbClr val="60758A"/>
                           </a:solidFill>
                           <a:latin typeface="Arial" pitchFamily="34" charset="0"/>
                           <a:ea typeface="Arial" pitchFamily="34" charset="-122"/>
                           <a:cs typeface="Arial" pitchFamily="34" charset="-120"/>
                         </a:rPr>
-                        <a:t>✓</a:t>
+                        <a:t>—</a:t>
                       </a:r>
                       <a:endParaRPr lang="en-US" sz="1100" dirty="0">
                         <a:latin typeface="Arial" charset="0"/>
@@ -10516,15 +10516,15 @@
                         <a:buNone/>
                       </a:pPr>
                       <a:r>
-                        <a:rPr lang="en-US" sz="1100" dirty="0">
+                        <a:rPr lang="en-US" sz="1100" b="1" dirty="0">
                           <a:solidFill>
-                            <a:srgbClr val="60758A"/>
+                            <a:srgbClr val="169873"/>
                           </a:solidFill>
                           <a:latin typeface="Arial" pitchFamily="34" charset="0"/>
                           <a:ea typeface="Arial" pitchFamily="34" charset="-122"/>
                           <a:cs typeface="Arial" pitchFamily="34" charset="-120"/>
                         </a:rPr>
-                        <a:t>—</a:t>
+                        <a:t>✓</a:t>
                       </a:r>
                       <a:endParaRPr lang="en-US" sz="1100" dirty="0">
                         <a:latin typeface="Arial" charset="0"/>
@@ -10581,15 +10581,15 @@
                         <a:buNone/>
                       </a:pPr>
                       <a:r>
-                        <a:rPr lang="en-US" sz="1100" b="1" dirty="0">
+                        <a:rPr lang="en-US" sz="1100" dirty="0">
                           <a:solidFill>
-                            <a:srgbClr val="169873"/>
+                            <a:srgbClr val="60758A"/>
                           </a:solidFill>
                           <a:latin typeface="Arial" pitchFamily="34" charset="0"/>
                           <a:ea typeface="Arial" pitchFamily="34" charset="-122"/>
                           <a:cs typeface="Arial" pitchFamily="34" charset="-120"/>
                         </a:rPr>
-                        <a:t>✓</a:t>
+                        <a:t>—</a:t>
                       </a:r>
                       <a:endParaRPr lang="en-US" sz="1100" dirty="0">
                         <a:latin typeface="Arial" charset="0"/>
@@ -10843,15 +10843,15 @@
                         <a:buNone/>
                       </a:pPr>
                       <a:r>
-                        <a:rPr lang="en-US" sz="1100" dirty="0">
+                        <a:rPr lang="en-US" sz="1100" b="1" dirty="0">
                           <a:solidFill>
-                            <a:srgbClr val="60758A"/>
+                            <a:srgbClr val="169873"/>
                           </a:solidFill>
                           <a:latin typeface="Arial" pitchFamily="34" charset="0"/>
                           <a:ea typeface="Arial" pitchFamily="34" charset="-122"/>
                           <a:cs typeface="Arial" pitchFamily="34" charset="-120"/>
                         </a:rPr>
-                        <a:t>—</a:t>
+                        <a:t>✓</a:t>
                       </a:r>
                       <a:endParaRPr lang="en-US" sz="1100" dirty="0">
                         <a:latin typeface="Arial" charset="0"/>
@@ -10908,15 +10908,15 @@
                         <a:buNone/>
                       </a:pPr>
                       <a:r>
-                        <a:rPr lang="en-US" sz="1100" b="1" dirty="0">
+                        <a:rPr lang="en-US" sz="1100" dirty="0">
                           <a:solidFill>
-                            <a:srgbClr val="169873"/>
+                            <a:srgbClr val="60758A"/>
                           </a:solidFill>
                           <a:latin typeface="Arial" pitchFamily="34" charset="0"/>
                           <a:ea typeface="Arial" pitchFamily="34" charset="-122"/>
                           <a:cs typeface="Arial" pitchFamily="34" charset="-120"/>
                         </a:rPr>
-                        <a:t>✓</a:t>
+                        <a:t>—</a:t>
                       </a:r>
                       <a:endParaRPr lang="en-US" sz="1100" dirty="0">
                         <a:latin typeface="Arial" charset="0"/>
@@ -11217,7 +11217,7 @@
                           <a:ea typeface="Arial" pitchFamily="34" charset="-122"/>
                           <a:cs typeface="Arial" pitchFamily="34" charset="-120"/>
                         </a:rPr>
-                        <a:t>EASTBAY PH-2 TP</a:t>
+                        <a:t>HTT STP</a:t>
                       </a:r>
                       <a:endParaRPr lang="en-US" sz="900" dirty="0">
                         <a:latin typeface="Arial" charset="0"/>
@@ -11285,7 +11285,7 @@
                           <a:ea typeface="Arial" pitchFamily="34" charset="-122"/>
                           <a:cs typeface="Arial" pitchFamily="34" charset="-120"/>
                         </a:rPr>
-                        <a:t>HTT STP</a:t>
+                        <a:t>EASTBAY PH-2 TP</a:t>
                       </a:r>
                       <a:endParaRPr lang="en-US" sz="900" dirty="0">
                         <a:latin typeface="Arial" charset="0"/>
@@ -11545,15 +11545,15 @@
                         <a:buNone/>
                       </a:pPr>
                       <a:r>
-                        <a:rPr lang="en-US" sz="1100" dirty="0">
+                        <a:rPr lang="en-US" sz="1100" b="1" dirty="0">
                           <a:solidFill>
-                            <a:srgbClr val="60758A"/>
+                            <a:srgbClr val="169873"/>
                           </a:solidFill>
                           <a:latin typeface="Arial" pitchFamily="34" charset="0"/>
                           <a:ea typeface="Arial" pitchFamily="34" charset="-122"/>
                           <a:cs typeface="Arial" pitchFamily="34" charset="-120"/>
                         </a:rPr>
-                        <a:t>—</a:t>
+                        <a:t>✓</a:t>
                       </a:r>
                       <a:endParaRPr lang="en-US" sz="1100" dirty="0">
                         <a:latin typeface="Arial" charset="0"/>
@@ -11610,15 +11610,15 @@
                         <a:buNone/>
                       </a:pPr>
                       <a:r>
-                        <a:rPr lang="en-US" sz="1100" b="1" dirty="0">
+                        <a:rPr lang="en-US" sz="1100" dirty="0">
                           <a:solidFill>
-                            <a:srgbClr val="169873"/>
+                            <a:srgbClr val="60758A"/>
                           </a:solidFill>
                           <a:latin typeface="Arial" pitchFamily="34" charset="0"/>
                           <a:ea typeface="Arial" pitchFamily="34" charset="-122"/>
                           <a:cs typeface="Arial" pitchFamily="34" charset="-120"/>
                         </a:rPr>
-                        <a:t>✓</a:t>
+                        <a:t>—</a:t>
                       </a:r>
                       <a:endParaRPr lang="en-US" sz="1100" dirty="0">
                         <a:latin typeface="Arial" charset="0"/>
@@ -11872,15 +11872,15 @@
                         <a:buNone/>
                       </a:pPr>
                       <a:r>
-                        <a:rPr lang="en-US" sz="1100" dirty="0">
+                        <a:rPr lang="en-US" sz="1100" b="1" dirty="0">
                           <a:solidFill>
-                            <a:srgbClr val="60758A"/>
+                            <a:srgbClr val="169873"/>
                           </a:solidFill>
                           <a:latin typeface="Arial" pitchFamily="34" charset="0"/>
                           <a:ea typeface="Arial" pitchFamily="34" charset="-122"/>
                           <a:cs typeface="Arial" pitchFamily="34" charset="-120"/>
                         </a:rPr>
-                        <a:t>—</a:t>
+                        <a:t>✓</a:t>
                       </a:r>
                       <a:endParaRPr lang="en-US" sz="1100" dirty="0">
                         <a:latin typeface="Arial" charset="0"/>
@@ -11937,15 +11937,15 @@
                         <a:buNone/>
                       </a:pPr>
                       <a:r>
-                        <a:rPr lang="en-US" sz="1100" b="1" dirty="0">
+                        <a:rPr lang="en-US" sz="1100" dirty="0">
                           <a:solidFill>
-                            <a:srgbClr val="169873"/>
+                            <a:srgbClr val="60758A"/>
                           </a:solidFill>
                           <a:latin typeface="Arial" pitchFamily="34" charset="0"/>
                           <a:ea typeface="Arial" pitchFamily="34" charset="-122"/>
                           <a:cs typeface="Arial" pitchFamily="34" charset="-120"/>
                         </a:rPr>
-                        <a:t>✓</a:t>
+                        <a:t>—</a:t>
                       </a:r>
                       <a:endParaRPr lang="en-US" sz="1100" dirty="0">
                         <a:latin typeface="Arial" charset="0"/>
@@ -12199,15 +12199,15 @@
                         <a:buNone/>
                       </a:pPr>
                       <a:r>
-                        <a:rPr lang="en-US" sz="1100" dirty="0">
+                        <a:rPr lang="en-US" sz="1100" b="1" dirty="0">
                           <a:solidFill>
-                            <a:srgbClr val="60758A"/>
+                            <a:srgbClr val="169873"/>
                           </a:solidFill>
                           <a:latin typeface="Arial" pitchFamily="34" charset="0"/>
                           <a:ea typeface="Arial" pitchFamily="34" charset="-122"/>
                           <a:cs typeface="Arial" pitchFamily="34" charset="-120"/>
                         </a:rPr>
-                        <a:t>—</a:t>
+                        <a:t>✓</a:t>
                       </a:r>
                       <a:endParaRPr lang="en-US" sz="1100" dirty="0">
                         <a:latin typeface="Arial" charset="0"/>
@@ -12264,15 +12264,15 @@
                         <a:buNone/>
                       </a:pPr>
                       <a:r>
-                        <a:rPr lang="en-US" sz="1100" b="1" dirty="0">
+                        <a:rPr lang="en-US" sz="1100" dirty="0">
                           <a:solidFill>
-                            <a:srgbClr val="169873"/>
+                            <a:srgbClr val="60758A"/>
                           </a:solidFill>
                           <a:latin typeface="Arial" pitchFamily="34" charset="0"/>
                           <a:ea typeface="Arial" pitchFamily="34" charset="-122"/>
                           <a:cs typeface="Arial" pitchFamily="34" charset="-120"/>
                         </a:rPr>
-                        <a:t>✓</a:t>
+                        <a:t>—</a:t>
                       </a:r>
                       <a:endParaRPr lang="en-US" sz="1100" dirty="0">
                         <a:latin typeface="Arial" charset="0"/>
@@ -12526,15 +12526,15 @@
                         <a:buNone/>
                       </a:pPr>
                       <a:r>
-                        <a:rPr lang="en-US" sz="1100" dirty="0">
+                        <a:rPr lang="en-US" sz="1100" b="1" dirty="0">
                           <a:solidFill>
-                            <a:srgbClr val="60758A"/>
+                            <a:srgbClr val="169873"/>
                           </a:solidFill>
                           <a:latin typeface="Arial" pitchFamily="34" charset="0"/>
                           <a:ea typeface="Arial" pitchFamily="34" charset="-122"/>
                           <a:cs typeface="Arial" pitchFamily="34" charset="-120"/>
                         </a:rPr>
-                        <a:t>—</a:t>
+                        <a:t>✓</a:t>
                       </a:r>
                       <a:endParaRPr lang="en-US" sz="1100" dirty="0">
                         <a:latin typeface="Arial" charset="0"/>
@@ -12591,15 +12591,15 @@
                         <a:buNone/>
                       </a:pPr>
                       <a:r>
-                        <a:rPr lang="en-US" sz="1100" b="1" dirty="0">
+                        <a:rPr lang="en-US" sz="1100" dirty="0">
                           <a:solidFill>
-                            <a:srgbClr val="169873"/>
+                            <a:srgbClr val="60758A"/>
                           </a:solidFill>
                           <a:latin typeface="Arial" pitchFamily="34" charset="0"/>
                           <a:ea typeface="Arial" pitchFamily="34" charset="-122"/>
                           <a:cs typeface="Arial" pitchFamily="34" charset="-120"/>
                         </a:rPr>
-                        <a:t>✓</a:t>
+                        <a:t>—</a:t>
                       </a:r>
                       <a:endParaRPr lang="en-US" sz="1100" dirty="0">
                         <a:latin typeface="Arial" charset="0"/>

</xml_diff>

<commit_message>
fix(governance-v3): correct exact approved TOC cells to approved matrix
- Update db/migrations/0016_governance_deliverable_status.sql seed

  AGLIPAY: 8, 11, 12

  HTT: 1, 2, 3, 4, 5, 6, 7, 8, 10, 11, 12

  EASTBAY: 2, 7, 8, 12

  KAYSAKAT: 8

- Update adapter.test.ts fixture and add regression tests

- Regenerate OM-Governance-Onboarding-Progress-TEST.pptx

- Keep PR #310 Draft
</commit_message>
<xml_diff>
--- a/OM-Governance-Onboarding-Progress-TEST.pptx
+++ b/OM-Governance-Onboarding-Progress-TEST.pptx
@@ -8816,15 +8816,15 @@
                         <a:buNone/>
                       </a:pPr>
                       <a:r>
-                        <a:rPr lang="en-US" sz="1100" b="1" dirty="0">
+                        <a:rPr lang="en-US" sz="1100" dirty="0">
                           <a:solidFill>
-                            <a:srgbClr val="169873"/>
+                            <a:srgbClr val="60758A"/>
                           </a:solidFill>
                           <a:latin typeface="Arial" pitchFamily="34" charset="0"/>
                           <a:ea typeface="Arial" pitchFamily="34" charset="-122"/>
                           <a:cs typeface="Arial" pitchFamily="34" charset="-120"/>
                         </a:rPr>
-                        <a:t>✓</a:t>
+                        <a:t>—</a:t>
                       </a:r>
                       <a:endParaRPr lang="en-US" sz="1100" dirty="0">
                         <a:latin typeface="Arial" charset="0"/>
@@ -8946,15 +8946,15 @@
                         <a:buNone/>
                       </a:pPr>
                       <a:r>
-                        <a:rPr lang="en-US" sz="1100" b="1" dirty="0">
+                        <a:rPr lang="en-US" sz="1100" dirty="0">
                           <a:solidFill>
-                            <a:srgbClr val="169873"/>
+                            <a:srgbClr val="60758A"/>
                           </a:solidFill>
                           <a:latin typeface="Arial" pitchFamily="34" charset="0"/>
                           <a:ea typeface="Arial" pitchFamily="34" charset="-122"/>
                           <a:cs typeface="Arial" pitchFamily="34" charset="-120"/>
                         </a:rPr>
-                        <a:t>✓</a:t>
+                        <a:t>—</a:t>
                       </a:r>
                       <a:endParaRPr lang="en-US" sz="1100" dirty="0">
                         <a:latin typeface="Arial" charset="0"/>
@@ -9011,15 +9011,15 @@
                         <a:buNone/>
                       </a:pPr>
                       <a:r>
-                        <a:rPr lang="en-US" sz="1100" b="1" dirty="0">
+                        <a:rPr lang="en-US" sz="1100" dirty="0">
                           <a:solidFill>
-                            <a:srgbClr val="169873"/>
+                            <a:srgbClr val="60758A"/>
                           </a:solidFill>
                           <a:latin typeface="Arial" pitchFamily="34" charset="0"/>
                           <a:ea typeface="Arial" pitchFamily="34" charset="-122"/>
                           <a:cs typeface="Arial" pitchFamily="34" charset="-120"/>
                         </a:rPr>
-                        <a:t>✓</a:t>
+                        <a:t>—</a:t>
                       </a:r>
                       <a:endParaRPr lang="en-US" sz="1100" dirty="0">
                         <a:latin typeface="Arial" charset="0"/>
@@ -9470,15 +9470,15 @@
                         <a:buNone/>
                       </a:pPr>
                       <a:r>
-                        <a:rPr lang="en-US" sz="1100" b="1" dirty="0">
+                        <a:rPr lang="en-US" sz="1100" dirty="0">
                           <a:solidFill>
-                            <a:srgbClr val="169873"/>
+                            <a:srgbClr val="60758A"/>
                           </a:solidFill>
                           <a:latin typeface="Arial" pitchFamily="34" charset="0"/>
                           <a:ea typeface="Arial" pitchFamily="34" charset="-122"/>
                           <a:cs typeface="Arial" pitchFamily="34" charset="-120"/>
                         </a:rPr>
-                        <a:t>✓</a:t>
+                        <a:t>—</a:t>
                       </a:r>
                       <a:endParaRPr lang="en-US" sz="1100" dirty="0">
                         <a:latin typeface="Arial" charset="0"/>
@@ -9600,15 +9600,15 @@
                         <a:buNone/>
                       </a:pPr>
                       <a:r>
-                        <a:rPr lang="en-US" sz="1100" b="1" dirty="0">
+                        <a:rPr lang="en-US" sz="1100" dirty="0">
                           <a:solidFill>
-                            <a:srgbClr val="169873"/>
+                            <a:srgbClr val="60758A"/>
                           </a:solidFill>
                           <a:latin typeface="Arial" pitchFamily="34" charset="0"/>
                           <a:ea typeface="Arial" pitchFamily="34" charset="-122"/>
                           <a:cs typeface="Arial" pitchFamily="34" charset="-120"/>
                         </a:rPr>
-                        <a:t>✓</a:t>
+                        <a:t>—</a:t>
                       </a:r>
                       <a:endParaRPr lang="en-US" sz="1100" dirty="0">
                         <a:latin typeface="Arial" charset="0"/>
@@ -9797,15 +9797,15 @@
                         <a:buNone/>
                       </a:pPr>
                       <a:r>
-                        <a:rPr lang="en-US" sz="1100" b="1" dirty="0">
+                        <a:rPr lang="en-US" sz="1100" dirty="0">
                           <a:solidFill>
-                            <a:srgbClr val="169873"/>
+                            <a:srgbClr val="60758A"/>
                           </a:solidFill>
                           <a:latin typeface="Arial" pitchFamily="34" charset="0"/>
                           <a:ea typeface="Arial" pitchFamily="34" charset="-122"/>
                           <a:cs typeface="Arial" pitchFamily="34" charset="-120"/>
                         </a:rPr>
-                        <a:t>✓</a:t>
+                        <a:t>—</a:t>
                       </a:r>
                       <a:endParaRPr lang="en-US" sz="1100" dirty="0">
                         <a:latin typeface="Arial" charset="0"/>
@@ -9927,15 +9927,15 @@
                         <a:buNone/>
                       </a:pPr>
                       <a:r>
-                        <a:rPr lang="en-US" sz="1100" b="1" dirty="0">
+                        <a:rPr lang="en-US" sz="1100" dirty="0">
                           <a:solidFill>
-                            <a:srgbClr val="169873"/>
+                            <a:srgbClr val="60758A"/>
                           </a:solidFill>
                           <a:latin typeface="Arial" pitchFamily="34" charset="0"/>
                           <a:ea typeface="Arial" pitchFamily="34" charset="-122"/>
                           <a:cs typeface="Arial" pitchFamily="34" charset="-120"/>
                         </a:rPr>
-                        <a:t>✓</a:t>
+                        <a:t>—</a:t>
                       </a:r>
                       <a:endParaRPr lang="en-US" sz="1100" dirty="0">
                         <a:latin typeface="Arial" charset="0"/>
@@ -10908,15 +10908,15 @@
                         <a:buNone/>
                       </a:pPr>
                       <a:r>
-                        <a:rPr lang="en-US" sz="1100" dirty="0">
+                        <a:rPr lang="en-US" sz="1100" b="1" dirty="0">
                           <a:solidFill>
-                            <a:srgbClr val="60758A"/>
+                            <a:srgbClr val="169873"/>
                           </a:solidFill>
                           <a:latin typeface="Arial" pitchFamily="34" charset="0"/>
                           <a:ea typeface="Arial" pitchFamily="34" charset="-122"/>
                           <a:cs typeface="Arial" pitchFamily="34" charset="-120"/>
                         </a:rPr>
-                        <a:t>—</a:t>
+                        <a:t>✓</a:t>
                       </a:r>
                       <a:endParaRPr lang="en-US" sz="1100" dirty="0">
                         <a:latin typeface="Arial" charset="0"/>
@@ -11480,15 +11480,15 @@
                         <a:buNone/>
                       </a:pPr>
                       <a:r>
-                        <a:rPr lang="en-US" sz="1100" dirty="0">
+                        <a:rPr lang="en-US" sz="1100" b="1" dirty="0">
                           <a:solidFill>
-                            <a:srgbClr val="60758A"/>
+                            <a:srgbClr val="169873"/>
                           </a:solidFill>
                           <a:latin typeface="Arial" pitchFamily="34" charset="0"/>
                           <a:ea typeface="Arial" pitchFamily="34" charset="-122"/>
                           <a:cs typeface="Arial" pitchFamily="34" charset="-120"/>
                         </a:rPr>
-                        <a:t>—</a:t>
+                        <a:t>✓</a:t>
                       </a:r>
                       <a:endParaRPr lang="en-US" sz="1100" dirty="0">
                         <a:latin typeface="Arial" charset="0"/>
@@ -11610,15 +11610,15 @@
                         <a:buNone/>
                       </a:pPr>
                       <a:r>
-                        <a:rPr lang="en-US" sz="1100" dirty="0">
+                        <a:rPr lang="en-US" sz="1100" b="1" dirty="0">
                           <a:solidFill>
-                            <a:srgbClr val="60758A"/>
+                            <a:srgbClr val="169873"/>
                           </a:solidFill>
                           <a:latin typeface="Arial" pitchFamily="34" charset="0"/>
                           <a:ea typeface="Arial" pitchFamily="34" charset="-122"/>
                           <a:cs typeface="Arial" pitchFamily="34" charset="-120"/>
                         </a:rPr>
-                        <a:t>—</a:t>
+                        <a:t>✓</a:t>
                       </a:r>
                       <a:endParaRPr lang="en-US" sz="1100" dirty="0">
                         <a:latin typeface="Arial" charset="0"/>
@@ -11675,15 +11675,15 @@
                         <a:buNone/>
                       </a:pPr>
                       <a:r>
-                        <a:rPr lang="en-US" sz="1100" dirty="0">
+                        <a:rPr lang="en-US" sz="1100" b="1" dirty="0">
                           <a:solidFill>
-                            <a:srgbClr val="60758A"/>
+                            <a:srgbClr val="169873"/>
                           </a:solidFill>
                           <a:latin typeface="Arial" pitchFamily="34" charset="0"/>
                           <a:ea typeface="Arial" pitchFamily="34" charset="-122"/>
                           <a:cs typeface="Arial" pitchFamily="34" charset="-120"/>
                         </a:rPr>
-                        <a:t>—</a:t>
+                        <a:t>✓</a:t>
                       </a:r>
                       <a:endParaRPr lang="en-US" sz="1100" dirty="0">
                         <a:latin typeface="Arial" charset="0"/>
@@ -11872,15 +11872,15 @@
                         <a:buNone/>
                       </a:pPr>
                       <a:r>
-                        <a:rPr lang="en-US" sz="1100" b="1" dirty="0">
+                        <a:rPr lang="en-US" sz="1100" dirty="0">
                           <a:solidFill>
-                            <a:srgbClr val="169873"/>
+                            <a:srgbClr val="60758A"/>
                           </a:solidFill>
                           <a:latin typeface="Arial" pitchFamily="34" charset="0"/>
                           <a:ea typeface="Arial" pitchFamily="34" charset="-122"/>
                           <a:cs typeface="Arial" pitchFamily="34" charset="-120"/>
                         </a:rPr>
-                        <a:t>✓</a:t>
+                        <a:t>—</a:t>
                       </a:r>
                       <a:endParaRPr lang="en-US" sz="1100" dirty="0">
                         <a:latin typeface="Arial" charset="0"/>
@@ -12461,15 +12461,15 @@
                         <a:buNone/>
                       </a:pPr>
                       <a:r>
-                        <a:rPr lang="en-US" sz="1100" dirty="0">
+                        <a:rPr lang="en-US" sz="1100" b="1" dirty="0">
                           <a:solidFill>
-                            <a:srgbClr val="60758A"/>
+                            <a:srgbClr val="169873"/>
                           </a:solidFill>
                           <a:latin typeface="Arial" pitchFamily="34" charset="0"/>
                           <a:ea typeface="Arial" pitchFamily="34" charset="-122"/>
                           <a:cs typeface="Arial" pitchFamily="34" charset="-120"/>
                         </a:rPr>
-                        <a:t>—</a:t>
+                        <a:t>✓</a:t>
                       </a:r>
                       <a:endParaRPr lang="en-US" sz="1100" dirty="0">
                         <a:latin typeface="Arial" charset="0"/>
@@ -12788,15 +12788,15 @@
                         <a:buNone/>
                       </a:pPr>
                       <a:r>
-                        <a:rPr lang="en-US" sz="1100" dirty="0">
+                        <a:rPr lang="en-US" sz="1100" b="1" dirty="0">
                           <a:solidFill>
-                            <a:srgbClr val="60758A"/>
+                            <a:srgbClr val="169873"/>
                           </a:solidFill>
                           <a:latin typeface="Arial" pitchFamily="34" charset="0"/>
                           <a:ea typeface="Arial" pitchFamily="34" charset="-122"/>
                           <a:cs typeface="Arial" pitchFamily="34" charset="-120"/>
                         </a:rPr>
-                        <a:t>—</a:t>
+                        <a:t>✓</a:t>
                       </a:r>
                       <a:endParaRPr lang="en-US" sz="1100" dirty="0">
                         <a:latin typeface="Arial" charset="0"/>
@@ -12853,15 +12853,15 @@
                         <a:buNone/>
                       </a:pPr>
                       <a:r>
-                        <a:rPr lang="en-US" sz="1100" dirty="0">
+                        <a:rPr lang="en-US" sz="1100" b="1" dirty="0">
                           <a:solidFill>
-                            <a:srgbClr val="60758A"/>
+                            <a:srgbClr val="169873"/>
                           </a:solidFill>
                           <a:latin typeface="Arial" pitchFamily="34" charset="0"/>
                           <a:ea typeface="Arial" pitchFamily="34" charset="-122"/>
                           <a:cs typeface="Arial" pitchFamily="34" charset="-120"/>
                         </a:rPr>
-                        <a:t>—</a:t>
+                        <a:t>✓</a:t>
                       </a:r>
                       <a:endParaRPr lang="en-US" sz="1100" dirty="0">
                         <a:latin typeface="Arial" charset="0"/>
@@ -12918,15 +12918,15 @@
                         <a:buNone/>
                       </a:pPr>
                       <a:r>
-                        <a:rPr lang="en-US" sz="1100" dirty="0">
+                        <a:rPr lang="en-US" sz="1100" b="1" dirty="0">
                           <a:solidFill>
-                            <a:srgbClr val="60758A"/>
+                            <a:srgbClr val="169873"/>
                           </a:solidFill>
                           <a:latin typeface="Arial" pitchFamily="34" charset="0"/>
                           <a:ea typeface="Arial" pitchFamily="34" charset="-122"/>
                           <a:cs typeface="Arial" pitchFamily="34" charset="-120"/>
                         </a:rPr>
-                        <a:t>—</a:t>
+                        <a:t>✓</a:t>
                       </a:r>
                       <a:endParaRPr lang="en-US" sz="1100" dirty="0">
                         <a:latin typeface="Arial" charset="0"/>

</xml_diff>